<commit_message>
Migrate legacy user roles to current admin model
</commit_message>
<xml_diff>
--- a/outputs/nexus-business-demo.pptx
+++ b/outputs/nexus-business-demo.pptx
@@ -2,14 +2,14 @@
 <file path=ppt/presentation.xml><?xml version="1.0" encoding="utf-8"?>
 <p:presentation xmlns:p="http://schemas.openxmlformats.org/presentationml/2006/main">
   <p:sldMasterIdLst>
-    <p:sldMasterId xmlns:r="http://schemas.openxmlformats.org/officeDocument/2006/relationships" id="2147483648" r:id="R0baf6a2b3aef4f48"/>
+    <p:sldMasterId xmlns:r="http://schemas.openxmlformats.org/officeDocument/2006/relationships" id="2147483648" r:id="R528a58d9144149e2"/>
   </p:sldMasterIdLst>
   <p:notesMasterIdLst>
-    <p:notesMasterId xmlns:r="http://schemas.openxmlformats.org/officeDocument/2006/relationships" r:id="R95312a27a35a43bd"/>
+    <p:notesMasterId xmlns:r="http://schemas.openxmlformats.org/officeDocument/2006/relationships" r:id="Rd265e7c9d4644893"/>
   </p:notesMasterIdLst>
   <p:sldIdLst>
-    <p:sldId xmlns:r="http://schemas.openxmlformats.org/officeDocument/2006/relationships" id="256" r:id="R93b683354dd14e81"/>
-    <p:sldId xmlns:r="http://schemas.openxmlformats.org/officeDocument/2006/relationships" id="257" r:id="R27d912e0403449e4"/>
+    <p:sldId xmlns:r="http://schemas.openxmlformats.org/officeDocument/2006/relationships" id="256" r:id="Rb06efecbbaaf4065"/>
+    <p:sldId xmlns:r="http://schemas.openxmlformats.org/officeDocument/2006/relationships" id="257" r:id="R5e1b2e3720c04544"/>
   </p:sldIdLst>
   <p:sldSz cx="12192000" cy="6858000"/>
   <p:notesSz cx="6858000" cy="9144000"/>
@@ -668,7 +668,7 @@
   </p:cSld>
   <p:clrMap bg1="lt1" tx1="dk1" bg2="lt2" tx2="dk2" accent1="accent1" accent2="accent2" accent3="accent3" accent4="accent4" accent5="accent5" accent6="accent6" hlink="hlink" folHlink="folHlink"/>
   <p:sldLayoutIdLst>
-    <p:sldLayoutId xmlns:r="http://schemas.openxmlformats.org/officeDocument/2006/relationships" id="2147483649" r:id="R0c35d06eb8cf4db4"/>
+    <p:sldLayoutId xmlns:r="http://schemas.openxmlformats.org/officeDocument/2006/relationships" id="2147483649" r:id="Rc741c3f2683a44d7"/>
   </p:sldLayoutIdLst>
   <p:txStyles>
     <p:titleStyle>
@@ -1219,7 +1219,7 @@
           <p:cNvPr id="1" name="brand-mark">
             <a:extLst xmlns:a="http://schemas.openxmlformats.org/drawingml/2006/main">
               <a:ext uri="{FF2B5EF4-FFF2-40B4-BE49-F238E27FC236}">
-                <a16:creationId xmlns:a16="http://schemas.microsoft.com/office/drawing/2014/main" id="{EB3E75D8-F600-462D-A5B7-C3F12EB75775}"/>
+                <a16:creationId xmlns:a16="http://schemas.microsoft.com/office/drawing/2014/main" id="{7620932E-6CDB-4B65-A9CC-795C2F93E1AD}"/>
               </a:ext>
             </a:extLst>
           </p:cNvPr>
@@ -1252,7 +1252,7 @@
           <p:cNvPr id="2" name="brand-word">
             <a:extLst xmlns:a="http://schemas.openxmlformats.org/drawingml/2006/main">
               <a:ext uri="{FF2B5EF4-FFF2-40B4-BE49-F238E27FC236}">
-                <a16:creationId xmlns:a16="http://schemas.microsoft.com/office/drawing/2014/main" id="{F9302089-3722-4560-9572-79887B4F9560}"/>
+                <a16:creationId xmlns:a16="http://schemas.microsoft.com/office/drawing/2014/main" id="{2E9B9A6D-B332-4B31-AF67-3106A8377C97}"/>
               </a:ext>
             </a:extLst>
           </p:cNvPr>
@@ -1305,22 +1305,22 @@
       </p:sp>
       <p:sp>
         <p:nvSpPr>
-          <p:cNvPr id="3" name="demo-pill-bg">
-            <a:extLst xmlns:a="http://schemas.openxmlformats.org/drawingml/2006/main">
-              <a:ext uri="{FF2B5EF4-FFF2-40B4-BE49-F238E27FC236}">
-                <a16:creationId xmlns:a16="http://schemas.microsoft.com/office/drawing/2014/main" id="{6B267CFE-F12D-43E9-9D27-9BEB8EB6A366}"/>
-              </a:ext>
-            </a:extLst>
-          </p:cNvPr>
-          <p:cNvSpPr>
-            <a:spLocks xmlns:a="http://schemas.openxmlformats.org/drawingml/2006/main" noGrp="1"/>
-          </p:cNvSpPr>
-          <p:nvPr/>
-        </p:nvSpPr>
-        <p:spPr>
-          <a:xfrm xmlns:a="http://schemas.openxmlformats.org/drawingml/2006/main">
-            <a:off x="685800" y="1333500"/>
-            <a:ext cx="1657350" cy="323850"/>
+          <p:cNvPr id="3" name="problem-pill-bg">
+            <a:extLst xmlns:a="http://schemas.openxmlformats.org/drawingml/2006/main">
+              <a:ext uri="{FF2B5EF4-FFF2-40B4-BE49-F238E27FC236}">
+                <a16:creationId xmlns:a16="http://schemas.microsoft.com/office/drawing/2014/main" id="{B4B51B21-C5B4-4170-A95F-1A135DA29F02}"/>
+              </a:ext>
+            </a:extLst>
+          </p:cNvPr>
+          <p:cNvSpPr>
+            <a:spLocks xmlns:a="http://schemas.openxmlformats.org/drawingml/2006/main" noGrp="1"/>
+          </p:cNvSpPr>
+          <p:nvPr/>
+        </p:nvSpPr>
+        <p:spPr>
+          <a:xfrm xmlns:a="http://schemas.openxmlformats.org/drawingml/2006/main">
+            <a:off x="685800" y="1257300"/>
+            <a:ext cx="2000250" cy="323850"/>
           </a:xfrm>
           <a:prstGeom xmlns:a="http://schemas.openxmlformats.org/drawingml/2006/main" prst="roundRect">
             <a:avLst>
@@ -1338,22 +1338,22 @@
       </p:sp>
       <p:sp>
         <p:nvSpPr>
-          <p:cNvPr id="4" name="demo-pill">
-            <a:extLst xmlns:a="http://schemas.openxmlformats.org/drawingml/2006/main">
-              <a:ext uri="{FF2B5EF4-FFF2-40B4-BE49-F238E27FC236}">
-                <a16:creationId xmlns:a16="http://schemas.microsoft.com/office/drawing/2014/main" id="{99F19456-139D-4F1C-9928-8BADAA2293A7}"/>
-              </a:ext>
-            </a:extLst>
-          </p:cNvPr>
-          <p:cNvSpPr>
-            <a:spLocks xmlns:a="http://schemas.openxmlformats.org/drawingml/2006/main" noGrp="1"/>
-          </p:cNvSpPr>
-          <p:nvPr/>
-        </p:nvSpPr>
-        <p:spPr>
-          <a:xfrm xmlns:a="http://schemas.openxmlformats.org/drawingml/2006/main">
-            <a:off x="838200" y="1400175"/>
-            <a:ext cx="1352550" cy="190500"/>
+          <p:cNvPr id="4" name="problem-pill">
+            <a:extLst xmlns:a="http://schemas.openxmlformats.org/drawingml/2006/main">
+              <a:ext uri="{FF2B5EF4-FFF2-40B4-BE49-F238E27FC236}">
+                <a16:creationId xmlns:a16="http://schemas.microsoft.com/office/drawing/2014/main" id="{3187BABD-AAF9-4825-A534-59EF7B9BE6B9}"/>
+              </a:ext>
+            </a:extLst>
+          </p:cNvPr>
+          <p:cNvSpPr>
+            <a:spLocks xmlns:a="http://schemas.openxmlformats.org/drawingml/2006/main" noGrp="1"/>
+          </p:cNvSpPr>
+          <p:nvPr/>
+        </p:nvSpPr>
+        <p:spPr>
+          <a:xfrm xmlns:a="http://schemas.openxmlformats.org/drawingml/2006/main">
+            <a:off x="838200" y="1323975"/>
+            <a:ext cx="1695450" cy="190500"/>
           </a:xfrm>
           <a:prstGeom xmlns:a="http://schemas.openxmlformats.org/drawingml/2006/main" prst="rect">
             <a:avLst/>
@@ -1387,29 +1387,29 @@
                 <a:ea typeface="Aptos"/>
                 <a:cs typeface="Aptos"/>
               </a:rPr>
-              <a:t>BUSINESS DEMO</a:t>
+              <a:t>PROBLEM STATEMENT</a:t>
             </a:r>
           </a:p>
         </p:txBody>
       </p:sp>
       <p:sp>
         <p:nvSpPr>
-          <p:cNvPr id="5" name="cover-title">
-            <a:extLst xmlns:a="http://schemas.openxmlformats.org/drawingml/2006/main">
-              <a:ext uri="{FF2B5EF4-FFF2-40B4-BE49-F238E27FC236}">
-                <a16:creationId xmlns:a16="http://schemas.microsoft.com/office/drawing/2014/main" id="{04AF55F3-33CE-4C0D-922F-2C93BC0AB07B}"/>
-              </a:ext>
-            </a:extLst>
-          </p:cNvPr>
-          <p:cNvSpPr>
-            <a:spLocks xmlns:a="http://schemas.openxmlformats.org/drawingml/2006/main" noGrp="1"/>
-          </p:cNvSpPr>
-          <p:nvPr/>
-        </p:nvSpPr>
-        <p:spPr>
-          <a:xfrm xmlns:a="http://schemas.openxmlformats.org/drawingml/2006/main">
-            <a:off x="685800" y="1924050"/>
-            <a:ext cx="7239000" cy="1352550"/>
+          <p:cNvPr id="5" name="problem-title">
+            <a:extLst xmlns:a="http://schemas.openxmlformats.org/drawingml/2006/main">
+              <a:ext uri="{FF2B5EF4-FFF2-40B4-BE49-F238E27FC236}">
+                <a16:creationId xmlns:a16="http://schemas.microsoft.com/office/drawing/2014/main" id="{66CC67B3-A0C3-4EC0-A90F-31D8BD0A91F6}"/>
+              </a:ext>
+            </a:extLst>
+          </p:cNvPr>
+          <p:cNvSpPr>
+            <a:spLocks xmlns:a="http://schemas.openxmlformats.org/drawingml/2006/main" noGrp="1"/>
+          </p:cNvSpPr>
+          <p:nvPr/>
+        </p:nvSpPr>
+        <p:spPr>
+          <a:xfrm xmlns:a="http://schemas.openxmlformats.org/drawingml/2006/main">
+            <a:off x="685800" y="1885950"/>
+            <a:ext cx="7334250" cy="1352550"/>
           </a:xfrm>
           <a:prstGeom xmlns:a="http://schemas.openxmlformats.org/drawingml/2006/main" prst="rect">
             <a:avLst/>
@@ -1425,7 +1425,7 @@
           <a:lstStyle xmlns:a="http://schemas.openxmlformats.org/drawingml/2006/main"/>
           <a:p xmlns:a="http://schemas.openxmlformats.org/drawingml/2006/main">
             <a:pPr algn="l">
-              <a:defRPr sz="4650" b="1">
+              <a:defRPr sz="4500" b="1">
                 <a:solidFill>
                   <a:srgbClr val="FFFFFF"/>
                 </a:solidFill>
@@ -1435,7 +1435,7 @@
               </a:defRPr>
             </a:pPr>
             <a:r>
-              <a:rPr sz="4650" b="1">
+              <a:rPr sz="4500" b="1">
                 <a:solidFill>
                   <a:srgbClr val="FFFFFF"/>
                 </a:solidFill>
@@ -1443,29 +1443,29 @@
                 <a:ea typeface="Aptos Display"/>
                 <a:cs typeface="Aptos Display"/>
               </a:rPr>
-              <a:t>Company knowledge, approved for AI</a:t>
+              <a:t>AI coding tools do not know the product</a:t>
             </a:r>
           </a:p>
         </p:txBody>
       </p:sp>
       <p:sp>
         <p:nvSpPr>
-          <p:cNvPr id="6" name="cover-subtitle">
-            <a:extLst xmlns:a="http://schemas.openxmlformats.org/drawingml/2006/main">
-              <a:ext uri="{FF2B5EF4-FFF2-40B4-BE49-F238E27FC236}">
-                <a16:creationId xmlns:a16="http://schemas.microsoft.com/office/drawing/2014/main" id="{99A85D2D-2604-44EB-8B8D-8837B12EFD24}"/>
-              </a:ext>
-            </a:extLst>
-          </p:cNvPr>
-          <p:cNvSpPr>
-            <a:spLocks xmlns:a="http://schemas.openxmlformats.org/drawingml/2006/main" noGrp="1"/>
-          </p:cNvSpPr>
-          <p:nvPr/>
-        </p:nvSpPr>
-        <p:spPr>
-          <a:xfrm xmlns:a="http://schemas.openxmlformats.org/drawingml/2006/main">
-            <a:off x="723900" y="3562350"/>
-            <a:ext cx="6572250" cy="819150"/>
+          <p:cNvPr id="6" name="problem-subtitle">
+            <a:extLst xmlns:a="http://schemas.openxmlformats.org/drawingml/2006/main">
+              <a:ext uri="{FF2B5EF4-FFF2-40B4-BE49-F238E27FC236}">
+                <a16:creationId xmlns:a16="http://schemas.microsoft.com/office/drawing/2014/main" id="{7F2753C5-6411-4E54-8523-F224A3C0E874}"/>
+              </a:ext>
+            </a:extLst>
+          </p:cNvPr>
+          <p:cNvSpPr>
+            <a:spLocks xmlns:a="http://schemas.openxmlformats.org/drawingml/2006/main" noGrp="1"/>
+          </p:cNvSpPr>
+          <p:nvPr/>
+        </p:nvSpPr>
+        <p:spPr>
+          <a:xfrm xmlns:a="http://schemas.openxmlformats.org/drawingml/2006/main">
+            <a:off x="723900" y="3505200"/>
+            <a:ext cx="6762750" cy="819150"/>
           </a:xfrm>
           <a:prstGeom xmlns:a="http://schemas.openxmlformats.org/drawingml/2006/main" prst="rect">
             <a:avLst/>
@@ -1481,7 +1481,7 @@
           <a:lstStyle xmlns:a="http://schemas.openxmlformats.org/drawingml/2006/main"/>
           <a:p xmlns:a="http://schemas.openxmlformats.org/drawingml/2006/main">
             <a:pPr algn="l">
-              <a:defRPr sz="1725" b="0">
+              <a:defRPr sz="1650" b="0">
                 <a:solidFill>
                   <a:srgbClr val="DDE2FF"/>
                 </a:solidFill>
@@ -1491,7 +1491,7 @@
               </a:defRPr>
             </a:pPr>
             <a:r>
-              <a:rPr sz="1725" b="0">
+              <a:rPr sz="1650" b="0">
                 <a:solidFill>
                   <a:srgbClr val="DDE2FF"/>
                 </a:solidFill>
@@ -1499,33 +1499,33 @@
                 <a:ea typeface="Aptos"/>
                 <a:cs typeface="Aptos"/>
               </a:rPr>
-              <a:t>Nexus gives teams a trusted way to turn scattered product knowledge into guidance that AI tools can safely reuse.</a:t>
+              <a:t>They can write code, but they do not automatically understand your product boundaries, decisions, standards, or missing context.</a:t>
             </a:r>
           </a:p>
         </p:txBody>
       </p:sp>
       <p:sp>
         <p:nvSpPr>
-          <p:cNvPr id="7" name="cover-demo-card">
-            <a:extLst xmlns:a="http://schemas.openxmlformats.org/drawingml/2006/main">
-              <a:ext uri="{FF2B5EF4-FFF2-40B4-BE49-F238E27FC236}">
-                <a16:creationId xmlns:a16="http://schemas.microsoft.com/office/drawing/2014/main" id="{92ABABF5-0AC4-4E1D-90F3-F7D2B1231E25}"/>
-              </a:ext>
-            </a:extLst>
-          </p:cNvPr>
-          <p:cNvSpPr>
-            <a:spLocks xmlns:a="http://schemas.openxmlformats.org/drawingml/2006/main" noGrp="1"/>
-          </p:cNvSpPr>
-          <p:nvPr/>
-        </p:nvSpPr>
-        <p:spPr>
-          <a:xfrm xmlns:a="http://schemas.openxmlformats.org/drawingml/2006/main">
-            <a:off x="8020050" y="1200150"/>
-            <a:ext cx="3238500" cy="4152900"/>
+          <p:cNvPr id="7" name="problem-card">
+            <a:extLst xmlns:a="http://schemas.openxmlformats.org/drawingml/2006/main">
+              <a:ext uri="{FF2B5EF4-FFF2-40B4-BE49-F238E27FC236}">
+                <a16:creationId xmlns:a16="http://schemas.microsoft.com/office/drawing/2014/main" id="{5768FAC5-290D-4D7B-B668-A45A8AAA0138}"/>
+              </a:ext>
+            </a:extLst>
+          </p:cNvPr>
+          <p:cNvSpPr>
+            <a:spLocks xmlns:a="http://schemas.openxmlformats.org/drawingml/2006/main" noGrp="1"/>
+          </p:cNvSpPr>
+          <p:nvPr/>
+        </p:nvSpPr>
+        <p:spPr>
+          <a:xfrm xmlns:a="http://schemas.openxmlformats.org/drawingml/2006/main">
+            <a:off x="8020050" y="1123950"/>
+            <a:ext cx="3333750" cy="4400550"/>
           </a:xfrm>
           <a:prstGeom xmlns:a="http://schemas.openxmlformats.org/drawingml/2006/main" prst="roundRect">
             <a:avLst>
-              <a:gd name="adj" fmla="val 4706"/>
+              <a:gd name="adj" fmla="val 4571"/>
             </a:avLst>
           </a:prstGeom>
           <a:solidFill xmlns:a="http://schemas.openxmlformats.org/drawingml/2006/main">
@@ -1541,21 +1541,21 @@
       </p:sp>
       <p:sp>
         <p:nvSpPr>
-          <p:cNvPr id="8" name="demo-card-title">
-            <a:extLst xmlns:a="http://schemas.openxmlformats.org/drawingml/2006/main">
-              <a:ext uri="{FF2B5EF4-FFF2-40B4-BE49-F238E27FC236}">
-                <a16:creationId xmlns:a16="http://schemas.microsoft.com/office/drawing/2014/main" id="{18957D0E-C2C4-45EF-A71D-724573367889}"/>
-              </a:ext>
-            </a:extLst>
-          </p:cNvPr>
-          <p:cNvSpPr>
-            <a:spLocks xmlns:a="http://schemas.openxmlformats.org/drawingml/2006/main" noGrp="1"/>
-          </p:cNvSpPr>
-          <p:nvPr/>
-        </p:nvSpPr>
-        <p:spPr>
-          <a:xfrm xmlns:a="http://schemas.openxmlformats.org/drawingml/2006/main">
-            <a:off x="8420100" y="1581150"/>
+          <p:cNvPr id="8" name="problem-card-title">
+            <a:extLst xmlns:a="http://schemas.openxmlformats.org/drawingml/2006/main">
+              <a:ext uri="{FF2B5EF4-FFF2-40B4-BE49-F238E27FC236}">
+                <a16:creationId xmlns:a16="http://schemas.microsoft.com/office/drawing/2014/main" id="{061B8B83-C7B7-4119-BB99-C582A3146692}"/>
+              </a:ext>
+            </a:extLst>
+          </p:cNvPr>
+          <p:cNvSpPr>
+            <a:spLocks xmlns:a="http://schemas.openxmlformats.org/drawingml/2006/main" noGrp="1"/>
+          </p:cNvSpPr>
+          <p:nvPr/>
+        </p:nvSpPr>
+        <p:spPr>
+          <a:xfrm xmlns:a="http://schemas.openxmlformats.org/drawingml/2006/main">
+            <a:off x="8420100" y="1504950"/>
             <a:ext cx="2286000" cy="304800"/>
           </a:xfrm>
           <a:prstGeom xmlns:a="http://schemas.openxmlformats.org/drawingml/2006/main" prst="rect">
@@ -1590,28 +1590,28 @@
                 <a:ea typeface="Aptos"/>
                 <a:cs typeface="Aptos"/>
               </a:rPr>
-              <a:t>Why it matters</a:t>
+              <a:t>What breaks</a:t>
             </a:r>
           </a:p>
         </p:txBody>
       </p:sp>
       <p:sp>
         <p:nvSpPr>
-          <p:cNvPr id="9" name="cover-step-dot-1">
-            <a:extLst xmlns:a="http://schemas.openxmlformats.org/drawingml/2006/main">
-              <a:ext uri="{FF2B5EF4-FFF2-40B4-BE49-F238E27FC236}">
-                <a16:creationId xmlns:a16="http://schemas.microsoft.com/office/drawing/2014/main" id="{236141AA-6F0E-469B-A02D-9677D6FA2C6C}"/>
-              </a:ext>
-            </a:extLst>
-          </p:cNvPr>
-          <p:cNvSpPr>
-            <a:spLocks xmlns:a="http://schemas.openxmlformats.org/drawingml/2006/main" noGrp="1"/>
-          </p:cNvSpPr>
-          <p:nvPr/>
-        </p:nvSpPr>
-        <p:spPr>
-          <a:xfrm xmlns:a="http://schemas.openxmlformats.org/drawingml/2006/main">
-            <a:off x="8629650" y="2209800"/>
+          <p:cNvPr id="9" name="problem-dot-1">
+            <a:extLst xmlns:a="http://schemas.openxmlformats.org/drawingml/2006/main">
+              <a:ext uri="{FF2B5EF4-FFF2-40B4-BE49-F238E27FC236}">
+                <a16:creationId xmlns:a16="http://schemas.microsoft.com/office/drawing/2014/main" id="{B29E1722-1938-4DAC-9D56-66913C411200}"/>
+              </a:ext>
+            </a:extLst>
+          </p:cNvPr>
+          <p:cNvSpPr>
+            <a:spLocks xmlns:a="http://schemas.openxmlformats.org/drawingml/2006/main" noGrp="1"/>
+          </p:cNvSpPr>
+          <p:nvPr/>
+        </p:nvSpPr>
+        <p:spPr>
+          <a:xfrm xmlns:a="http://schemas.openxmlformats.org/drawingml/2006/main">
+            <a:off x="8629650" y="2095500"/>
             <a:ext cx="285750" cy="285750"/>
           </a:xfrm>
           <a:prstGeom xmlns:a="http://schemas.openxmlformats.org/drawingml/2006/main" prst="ellipse">
@@ -1628,21 +1628,21 @@
       </p:sp>
       <p:sp>
         <p:nvSpPr>
-          <p:cNvPr id="10" name="cover-step-num-1">
-            <a:extLst xmlns:a="http://schemas.openxmlformats.org/drawingml/2006/main">
-              <a:ext uri="{FF2B5EF4-FFF2-40B4-BE49-F238E27FC236}">
-                <a16:creationId xmlns:a16="http://schemas.microsoft.com/office/drawing/2014/main" id="{1DDCCF0B-2BFA-4CDD-A982-6C33A28E1C83}"/>
-              </a:ext>
-            </a:extLst>
-          </p:cNvPr>
-          <p:cNvSpPr>
-            <a:spLocks xmlns:a="http://schemas.openxmlformats.org/drawingml/2006/main" noGrp="1"/>
-          </p:cNvSpPr>
-          <p:nvPr/>
-        </p:nvSpPr>
-        <p:spPr>
-          <a:xfrm xmlns:a="http://schemas.openxmlformats.org/drawingml/2006/main">
-            <a:off x="8705850" y="2257425"/>
+          <p:cNvPr id="10" name="problem-num-1">
+            <a:extLst xmlns:a="http://schemas.openxmlformats.org/drawingml/2006/main">
+              <a:ext uri="{FF2B5EF4-FFF2-40B4-BE49-F238E27FC236}">
+                <a16:creationId xmlns:a16="http://schemas.microsoft.com/office/drawing/2014/main" id="{6C19CD3C-19C2-4AA4-A4AF-DBA1FFD37D00}"/>
+              </a:ext>
+            </a:extLst>
+          </p:cNvPr>
+          <p:cNvSpPr>
+            <a:spLocks xmlns:a="http://schemas.openxmlformats.org/drawingml/2006/main" noGrp="1"/>
+          </p:cNvSpPr>
+          <p:nvPr/>
+        </p:nvSpPr>
+        <p:spPr>
+          <a:xfrm xmlns:a="http://schemas.openxmlformats.org/drawingml/2006/main">
+            <a:off x="8705850" y="2143125"/>
             <a:ext cx="133350" cy="171450"/>
           </a:xfrm>
           <a:prstGeom xmlns:a="http://schemas.openxmlformats.org/drawingml/2006/main" prst="rect">
@@ -1684,22 +1684,22 @@
       </p:sp>
       <p:sp>
         <p:nvSpPr>
-          <p:cNvPr id="11" name="cover-step-text-1">
-            <a:extLst xmlns:a="http://schemas.openxmlformats.org/drawingml/2006/main">
-              <a:ext uri="{FF2B5EF4-FFF2-40B4-BE49-F238E27FC236}">
-                <a16:creationId xmlns:a16="http://schemas.microsoft.com/office/drawing/2014/main" id="{66E7D2CE-EA14-45AA-B65C-E2B03E73BECB}"/>
-              </a:ext>
-            </a:extLst>
-          </p:cNvPr>
-          <p:cNvSpPr>
-            <a:spLocks xmlns:a="http://schemas.openxmlformats.org/drawingml/2006/main" noGrp="1"/>
-          </p:cNvSpPr>
-          <p:nvPr/>
-        </p:nvSpPr>
-        <p:spPr>
-          <a:xfrm xmlns:a="http://schemas.openxmlformats.org/drawingml/2006/main">
-            <a:off x="9086850" y="2209800"/>
-            <a:ext cx="1790700" cy="361950"/>
+          <p:cNvPr id="11" name="problem-text-1">
+            <a:extLst xmlns:a="http://schemas.openxmlformats.org/drawingml/2006/main">
+              <a:ext uri="{FF2B5EF4-FFF2-40B4-BE49-F238E27FC236}">
+                <a16:creationId xmlns:a16="http://schemas.microsoft.com/office/drawing/2014/main" id="{68E33A72-06F2-4A2F-A670-30F1719BEDC3}"/>
+              </a:ext>
+            </a:extLst>
+          </p:cNvPr>
+          <p:cNvSpPr>
+            <a:spLocks xmlns:a="http://schemas.openxmlformats.org/drawingml/2006/main" noGrp="1"/>
+          </p:cNvSpPr>
+          <p:nvPr/>
+        </p:nvSpPr>
+        <p:spPr>
+          <a:xfrm xmlns:a="http://schemas.openxmlformats.org/drawingml/2006/main">
+            <a:off x="9086850" y="2076450"/>
+            <a:ext cx="1905000" cy="361950"/>
           </a:xfrm>
           <a:prstGeom xmlns:a="http://schemas.openxmlformats.org/drawingml/2006/main" prst="rect">
             <a:avLst/>
@@ -1715,7 +1715,7 @@
           <a:lstStyle xmlns:a="http://schemas.openxmlformats.org/drawingml/2006/main"/>
           <a:p xmlns:a="http://schemas.openxmlformats.org/drawingml/2006/main">
             <a:pPr algn="l">
-              <a:defRPr sz="1350" b="0">
+              <a:defRPr sz="1275" b="0">
                 <a:solidFill>
                   <a:srgbClr val="FFFFFF"/>
                 </a:solidFill>
@@ -1725,7 +1725,7 @@
               </a:defRPr>
             </a:pPr>
             <a:r>
-              <a:rPr sz="1350" b="0">
+              <a:rPr sz="1275" b="0">
                 <a:solidFill>
                   <a:srgbClr val="FFFFFF"/>
                 </a:solidFill>
@@ -1733,28 +1733,28 @@
                 <a:ea typeface="Aptos"/>
                 <a:cs typeface="Aptos"/>
               </a:rPr>
-              <a:t>AI answers become consistent</a:t>
+              <a:t>Onboarding depends on tribal knowledge</a:t>
             </a:r>
           </a:p>
         </p:txBody>
       </p:sp>
       <p:sp>
         <p:nvSpPr>
-          <p:cNvPr id="12" name="cover-step-dot-2">
-            <a:extLst xmlns:a="http://schemas.openxmlformats.org/drawingml/2006/main">
-              <a:ext uri="{FF2B5EF4-FFF2-40B4-BE49-F238E27FC236}">
-                <a16:creationId xmlns:a16="http://schemas.microsoft.com/office/drawing/2014/main" id="{06C4CAB3-06F6-4107-B4CA-237BA3872131}"/>
-              </a:ext>
-            </a:extLst>
-          </p:cNvPr>
-          <p:cNvSpPr>
-            <a:spLocks xmlns:a="http://schemas.openxmlformats.org/drawingml/2006/main" noGrp="1"/>
-          </p:cNvSpPr>
-          <p:nvPr/>
-        </p:nvSpPr>
-        <p:spPr>
-          <a:xfrm xmlns:a="http://schemas.openxmlformats.org/drawingml/2006/main">
-            <a:off x="8629650" y="2838450"/>
+          <p:cNvPr id="12" name="problem-dot-2">
+            <a:extLst xmlns:a="http://schemas.openxmlformats.org/drawingml/2006/main">
+              <a:ext uri="{FF2B5EF4-FFF2-40B4-BE49-F238E27FC236}">
+                <a16:creationId xmlns:a16="http://schemas.microsoft.com/office/drawing/2014/main" id="{B179AC9E-B85E-4EBB-A146-4EB14727C930}"/>
+              </a:ext>
+            </a:extLst>
+          </p:cNvPr>
+          <p:cNvSpPr>
+            <a:spLocks xmlns:a="http://schemas.openxmlformats.org/drawingml/2006/main" noGrp="1"/>
+          </p:cNvSpPr>
+          <p:nvPr/>
+        </p:nvSpPr>
+        <p:spPr>
+          <a:xfrm xmlns:a="http://schemas.openxmlformats.org/drawingml/2006/main">
+            <a:off x="8629650" y="2647950"/>
             <a:ext cx="285750" cy="285750"/>
           </a:xfrm>
           <a:prstGeom xmlns:a="http://schemas.openxmlformats.org/drawingml/2006/main" prst="ellipse">
@@ -1771,21 +1771,21 @@
       </p:sp>
       <p:sp>
         <p:nvSpPr>
-          <p:cNvPr id="13" name="cover-step-num-2">
-            <a:extLst xmlns:a="http://schemas.openxmlformats.org/drawingml/2006/main">
-              <a:ext uri="{FF2B5EF4-FFF2-40B4-BE49-F238E27FC236}">
-                <a16:creationId xmlns:a16="http://schemas.microsoft.com/office/drawing/2014/main" id="{E9FCC290-C9A6-4885-BC3F-A7C486F9CBC2}"/>
-              </a:ext>
-            </a:extLst>
-          </p:cNvPr>
-          <p:cNvSpPr>
-            <a:spLocks xmlns:a="http://schemas.openxmlformats.org/drawingml/2006/main" noGrp="1"/>
-          </p:cNvSpPr>
-          <p:nvPr/>
-        </p:nvSpPr>
-        <p:spPr>
-          <a:xfrm xmlns:a="http://schemas.openxmlformats.org/drawingml/2006/main">
-            <a:off x="8705850" y="2886075"/>
+          <p:cNvPr id="13" name="problem-num-2">
+            <a:extLst xmlns:a="http://schemas.openxmlformats.org/drawingml/2006/main">
+              <a:ext uri="{FF2B5EF4-FFF2-40B4-BE49-F238E27FC236}">
+                <a16:creationId xmlns:a16="http://schemas.microsoft.com/office/drawing/2014/main" id="{E07379A8-8757-407C-8E7F-F3C168820EC9}"/>
+              </a:ext>
+            </a:extLst>
+          </p:cNvPr>
+          <p:cNvSpPr>
+            <a:spLocks xmlns:a="http://schemas.openxmlformats.org/drawingml/2006/main" noGrp="1"/>
+          </p:cNvSpPr>
+          <p:nvPr/>
+        </p:nvSpPr>
+        <p:spPr>
+          <a:xfrm xmlns:a="http://schemas.openxmlformats.org/drawingml/2006/main">
+            <a:off x="8705850" y="2695575"/>
             <a:ext cx="133350" cy="171450"/>
           </a:xfrm>
           <a:prstGeom xmlns:a="http://schemas.openxmlformats.org/drawingml/2006/main" prst="rect">
@@ -1827,22 +1827,22 @@
       </p:sp>
       <p:sp>
         <p:nvSpPr>
-          <p:cNvPr id="14" name="cover-step-text-2">
-            <a:extLst xmlns:a="http://schemas.openxmlformats.org/drawingml/2006/main">
-              <a:ext uri="{FF2B5EF4-FFF2-40B4-BE49-F238E27FC236}">
-                <a16:creationId xmlns:a16="http://schemas.microsoft.com/office/drawing/2014/main" id="{4C100AF8-7B36-487A-B492-86EB77AA5E93}"/>
-              </a:ext>
-            </a:extLst>
-          </p:cNvPr>
-          <p:cNvSpPr>
-            <a:spLocks xmlns:a="http://schemas.openxmlformats.org/drawingml/2006/main" noGrp="1"/>
-          </p:cNvSpPr>
-          <p:nvPr/>
-        </p:nvSpPr>
-        <p:spPr>
-          <a:xfrm xmlns:a="http://schemas.openxmlformats.org/drawingml/2006/main">
-            <a:off x="9086850" y="2838450"/>
-            <a:ext cx="1790700" cy="361950"/>
+          <p:cNvPr id="14" name="problem-text-2">
+            <a:extLst xmlns:a="http://schemas.openxmlformats.org/drawingml/2006/main">
+              <a:ext uri="{FF2B5EF4-FFF2-40B4-BE49-F238E27FC236}">
+                <a16:creationId xmlns:a16="http://schemas.microsoft.com/office/drawing/2014/main" id="{BFA0E076-F2A6-4146-9CEB-CB12C96602B8}"/>
+              </a:ext>
+            </a:extLst>
+          </p:cNvPr>
+          <p:cNvSpPr>
+            <a:spLocks xmlns:a="http://schemas.openxmlformats.org/drawingml/2006/main" noGrp="1"/>
+          </p:cNvSpPr>
+          <p:nvPr/>
+        </p:nvSpPr>
+        <p:spPr>
+          <a:xfrm xmlns:a="http://schemas.openxmlformats.org/drawingml/2006/main">
+            <a:off x="9086850" y="2628900"/>
+            <a:ext cx="1905000" cy="361950"/>
           </a:xfrm>
           <a:prstGeom xmlns:a="http://schemas.openxmlformats.org/drawingml/2006/main" prst="rect">
             <a:avLst/>
@@ -1858,7 +1858,7 @@
           <a:lstStyle xmlns:a="http://schemas.openxmlformats.org/drawingml/2006/main"/>
           <a:p xmlns:a="http://schemas.openxmlformats.org/drawingml/2006/main">
             <a:pPr algn="l">
-              <a:defRPr sz="1350" b="0">
+              <a:defRPr sz="1275" b="0">
                 <a:solidFill>
                   <a:srgbClr val="FFFFFF"/>
                 </a:solidFill>
@@ -1868,7 +1868,7 @@
               </a:defRPr>
             </a:pPr>
             <a:r>
-              <a:rPr sz="1350" b="0">
+              <a:rPr sz="1275" b="0">
                 <a:solidFill>
                   <a:srgbClr val="FFFFFF"/>
                 </a:solidFill>
@@ -1876,59 +1876,59 @@
                 <a:ea typeface="Aptos"/>
                 <a:cs typeface="Aptos"/>
               </a:rPr>
-              <a:t>Experts repeat themselves less</a:t>
+              <a:t>Gaps in docs and product rules stay hidden</a:t>
             </a:r>
           </a:p>
         </p:txBody>
       </p:sp>
       <p:sp>
         <p:nvSpPr>
-          <p:cNvPr id="15" name="cover-step-dot-3">
-            <a:extLst xmlns:a="http://schemas.openxmlformats.org/drawingml/2006/main">
-              <a:ext uri="{FF2B5EF4-FFF2-40B4-BE49-F238E27FC236}">
-                <a16:creationId xmlns:a16="http://schemas.microsoft.com/office/drawing/2014/main" id="{C444220D-FB62-454E-B800-DDE035FBA768}"/>
-              </a:ext>
-            </a:extLst>
-          </p:cNvPr>
-          <p:cNvSpPr>
-            <a:spLocks xmlns:a="http://schemas.openxmlformats.org/drawingml/2006/main" noGrp="1"/>
-          </p:cNvSpPr>
-          <p:nvPr/>
-        </p:nvSpPr>
-        <p:spPr>
-          <a:xfrm xmlns:a="http://schemas.openxmlformats.org/drawingml/2006/main">
-            <a:off x="8629650" y="3467100"/>
+          <p:cNvPr id="15" name="problem-dot-3">
+            <a:extLst xmlns:a="http://schemas.openxmlformats.org/drawingml/2006/main">
+              <a:ext uri="{FF2B5EF4-FFF2-40B4-BE49-F238E27FC236}">
+                <a16:creationId xmlns:a16="http://schemas.microsoft.com/office/drawing/2014/main" id="{5EF79398-4822-4158-91BD-20F9CD40C11A}"/>
+              </a:ext>
+            </a:extLst>
+          </p:cNvPr>
+          <p:cNvSpPr>
+            <a:spLocks xmlns:a="http://schemas.openxmlformats.org/drawingml/2006/main" noGrp="1"/>
+          </p:cNvSpPr>
+          <p:nvPr/>
+        </p:nvSpPr>
+        <p:spPr>
+          <a:xfrm xmlns:a="http://schemas.openxmlformats.org/drawingml/2006/main">
+            <a:off x="8629650" y="3200400"/>
             <a:ext cx="285750" cy="285750"/>
           </a:xfrm>
           <a:prstGeom xmlns:a="http://schemas.openxmlformats.org/drawingml/2006/main" prst="ellipse">
             <a:avLst/>
           </a:prstGeom>
           <a:solidFill xmlns:a="http://schemas.openxmlformats.org/drawingml/2006/main">
-            <a:srgbClr val="17B890"/>
-          </a:solidFill>
-          <a:ln xmlns:a="http://schemas.openxmlformats.org/drawingml/2006/main" w="0">
-            <a:noFill/>
-            <a:prstDash val="solid"/>
-          </a:ln>
-        </p:spPr>
-      </p:sp>
-      <p:sp>
-        <p:nvSpPr>
-          <p:cNvPr id="16" name="cover-step-num-3">
-            <a:extLst xmlns:a="http://schemas.openxmlformats.org/drawingml/2006/main">
-              <a:ext uri="{FF2B5EF4-FFF2-40B4-BE49-F238E27FC236}">
-                <a16:creationId xmlns:a16="http://schemas.microsoft.com/office/drawing/2014/main" id="{70EDB1F8-1266-4514-88A1-A535B51A71E5}"/>
-              </a:ext>
-            </a:extLst>
-          </p:cNvPr>
-          <p:cNvSpPr>
-            <a:spLocks xmlns:a="http://schemas.openxmlformats.org/drawingml/2006/main" noGrp="1"/>
-          </p:cNvSpPr>
-          <p:nvPr/>
-        </p:nvSpPr>
-        <p:spPr>
-          <a:xfrm xmlns:a="http://schemas.openxmlformats.org/drawingml/2006/main">
-            <a:off x="8705850" y="3514725"/>
+            <a:srgbClr val="FFB84D"/>
+          </a:solidFill>
+          <a:ln xmlns:a="http://schemas.openxmlformats.org/drawingml/2006/main" w="0">
+            <a:noFill/>
+            <a:prstDash val="solid"/>
+          </a:ln>
+        </p:spPr>
+      </p:sp>
+      <p:sp>
+        <p:nvSpPr>
+          <p:cNvPr id="16" name="problem-num-3">
+            <a:extLst xmlns:a="http://schemas.openxmlformats.org/drawingml/2006/main">
+              <a:ext uri="{FF2B5EF4-FFF2-40B4-BE49-F238E27FC236}">
+                <a16:creationId xmlns:a16="http://schemas.microsoft.com/office/drawing/2014/main" id="{45B83C4B-C223-4DF7-A106-4003DCB478FC}"/>
+              </a:ext>
+            </a:extLst>
+          </p:cNvPr>
+          <p:cNvSpPr>
+            <a:spLocks xmlns:a="http://schemas.openxmlformats.org/drawingml/2006/main" noGrp="1"/>
+          </p:cNvSpPr>
+          <p:nvPr/>
+        </p:nvSpPr>
+        <p:spPr>
+          <a:xfrm xmlns:a="http://schemas.openxmlformats.org/drawingml/2006/main">
+            <a:off x="8705850" y="3248025"/>
             <a:ext cx="133350" cy="171450"/>
           </a:xfrm>
           <a:prstGeom xmlns:a="http://schemas.openxmlformats.org/drawingml/2006/main" prst="rect">
@@ -1970,22 +1970,22 @@
       </p:sp>
       <p:sp>
         <p:nvSpPr>
-          <p:cNvPr id="17" name="cover-step-text-3">
-            <a:extLst xmlns:a="http://schemas.openxmlformats.org/drawingml/2006/main">
-              <a:ext uri="{FF2B5EF4-FFF2-40B4-BE49-F238E27FC236}">
-                <a16:creationId xmlns:a16="http://schemas.microsoft.com/office/drawing/2014/main" id="{57CD9BE3-3EF3-4071-88CE-E444E4E0DD47}"/>
-              </a:ext>
-            </a:extLst>
-          </p:cNvPr>
-          <p:cNvSpPr>
-            <a:spLocks xmlns:a="http://schemas.openxmlformats.org/drawingml/2006/main" noGrp="1"/>
-          </p:cNvSpPr>
-          <p:nvPr/>
-        </p:nvSpPr>
-        <p:spPr>
-          <a:xfrm xmlns:a="http://schemas.openxmlformats.org/drawingml/2006/main">
-            <a:off x="9086850" y="3467100"/>
-            <a:ext cx="1790700" cy="361950"/>
+          <p:cNvPr id="17" name="problem-text-3">
+            <a:extLst xmlns:a="http://schemas.openxmlformats.org/drawingml/2006/main">
+              <a:ext uri="{FF2B5EF4-FFF2-40B4-BE49-F238E27FC236}">
+                <a16:creationId xmlns:a16="http://schemas.microsoft.com/office/drawing/2014/main" id="{031ED8AF-A124-4602-9836-2ED5EDC93545}"/>
+              </a:ext>
+            </a:extLst>
+          </p:cNvPr>
+          <p:cNvSpPr>
+            <a:spLocks xmlns:a="http://schemas.openxmlformats.org/drawingml/2006/main" noGrp="1"/>
+          </p:cNvSpPr>
+          <p:nvPr/>
+        </p:nvSpPr>
+        <p:spPr>
+          <a:xfrm xmlns:a="http://schemas.openxmlformats.org/drawingml/2006/main">
+            <a:off x="9086850" y="3181350"/>
+            <a:ext cx="1905000" cy="361950"/>
           </a:xfrm>
           <a:prstGeom xmlns:a="http://schemas.openxmlformats.org/drawingml/2006/main" prst="rect">
             <a:avLst/>
@@ -2001,7 +2001,7 @@
           <a:lstStyle xmlns:a="http://schemas.openxmlformats.org/drawingml/2006/main"/>
           <a:p xmlns:a="http://schemas.openxmlformats.org/drawingml/2006/main">
             <a:pPr algn="l">
-              <a:defRPr sz="1350" b="0">
+              <a:defRPr sz="1275" b="0">
                 <a:solidFill>
                   <a:srgbClr val="FFFFFF"/>
                 </a:solidFill>
@@ -2011,7 +2011,7 @@
               </a:defRPr>
             </a:pPr>
             <a:r>
-              <a:rPr sz="1350" b="0">
+              <a:rPr sz="1275" b="0">
                 <a:solidFill>
                   <a:srgbClr val="FFFFFF"/>
                 </a:solidFill>
@@ -2019,28 +2019,28 @@
                 <a:ea typeface="Aptos"/>
                 <a:cs typeface="Aptos"/>
               </a:rPr>
-              <a:t>Official guidance has an approval gate</a:t>
+              <a:t>AI guesses, causing hallucinations</a:t>
             </a:r>
           </a:p>
         </p:txBody>
       </p:sp>
       <p:sp>
         <p:nvSpPr>
-          <p:cNvPr id="18" name="cover-step-dot-4">
-            <a:extLst xmlns:a="http://schemas.openxmlformats.org/drawingml/2006/main">
-              <a:ext uri="{FF2B5EF4-FFF2-40B4-BE49-F238E27FC236}">
-                <a16:creationId xmlns:a16="http://schemas.microsoft.com/office/drawing/2014/main" id="{4CC3F2E5-D383-462E-A8CE-4FE3BEFAC6AE}"/>
-              </a:ext>
-            </a:extLst>
-          </p:cNvPr>
-          <p:cNvSpPr>
-            <a:spLocks xmlns:a="http://schemas.openxmlformats.org/drawingml/2006/main" noGrp="1"/>
-          </p:cNvSpPr>
-          <p:nvPr/>
-        </p:nvSpPr>
-        <p:spPr>
-          <a:xfrm xmlns:a="http://schemas.openxmlformats.org/drawingml/2006/main">
-            <a:off x="8629650" y="4095750"/>
+          <p:cNvPr id="18" name="problem-dot-4">
+            <a:extLst xmlns:a="http://schemas.openxmlformats.org/drawingml/2006/main">
+              <a:ext uri="{FF2B5EF4-FFF2-40B4-BE49-F238E27FC236}">
+                <a16:creationId xmlns:a16="http://schemas.microsoft.com/office/drawing/2014/main" id="{6E105077-B59F-4A1D-A46D-C700C669B4ED}"/>
+              </a:ext>
+            </a:extLst>
+          </p:cNvPr>
+          <p:cNvSpPr>
+            <a:spLocks xmlns:a="http://schemas.openxmlformats.org/drawingml/2006/main" noGrp="1"/>
+          </p:cNvSpPr>
+          <p:nvPr/>
+        </p:nvSpPr>
+        <p:spPr>
+          <a:xfrm xmlns:a="http://schemas.openxmlformats.org/drawingml/2006/main">
+            <a:off x="8629650" y="3752850"/>
             <a:ext cx="285750" cy="285750"/>
           </a:xfrm>
           <a:prstGeom xmlns:a="http://schemas.openxmlformats.org/drawingml/2006/main" prst="ellipse">
@@ -2057,21 +2057,21 @@
       </p:sp>
       <p:sp>
         <p:nvSpPr>
-          <p:cNvPr id="19" name="cover-step-num-4">
-            <a:extLst xmlns:a="http://schemas.openxmlformats.org/drawingml/2006/main">
-              <a:ext uri="{FF2B5EF4-FFF2-40B4-BE49-F238E27FC236}">
-                <a16:creationId xmlns:a16="http://schemas.microsoft.com/office/drawing/2014/main" id="{F5F293EB-C744-498E-9DAC-0FF36FDDCB1D}"/>
-              </a:ext>
-            </a:extLst>
-          </p:cNvPr>
-          <p:cNvSpPr>
-            <a:spLocks xmlns:a="http://schemas.openxmlformats.org/drawingml/2006/main" noGrp="1"/>
-          </p:cNvSpPr>
-          <p:nvPr/>
-        </p:nvSpPr>
-        <p:spPr>
-          <a:xfrm xmlns:a="http://schemas.openxmlformats.org/drawingml/2006/main">
-            <a:off x="8705850" y="4143375"/>
+          <p:cNvPr id="19" name="problem-num-4">
+            <a:extLst xmlns:a="http://schemas.openxmlformats.org/drawingml/2006/main">
+              <a:ext uri="{FF2B5EF4-FFF2-40B4-BE49-F238E27FC236}">
+                <a16:creationId xmlns:a16="http://schemas.microsoft.com/office/drawing/2014/main" id="{272A37D8-A23D-4E68-8A42-10EA877BDB87}"/>
+              </a:ext>
+            </a:extLst>
+          </p:cNvPr>
+          <p:cNvSpPr>
+            <a:spLocks xmlns:a="http://schemas.openxmlformats.org/drawingml/2006/main" noGrp="1"/>
+          </p:cNvSpPr>
+          <p:nvPr/>
+        </p:nvSpPr>
+        <p:spPr>
+          <a:xfrm xmlns:a="http://schemas.openxmlformats.org/drawingml/2006/main">
+            <a:off x="8705850" y="3800475"/>
             <a:ext cx="133350" cy="171450"/>
           </a:xfrm>
           <a:prstGeom xmlns:a="http://schemas.openxmlformats.org/drawingml/2006/main" prst="rect">
@@ -2113,22 +2113,22 @@
       </p:sp>
       <p:sp>
         <p:nvSpPr>
-          <p:cNvPr id="20" name="cover-step-text-4">
-            <a:extLst xmlns:a="http://schemas.openxmlformats.org/drawingml/2006/main">
-              <a:ext uri="{FF2B5EF4-FFF2-40B4-BE49-F238E27FC236}">
-                <a16:creationId xmlns:a16="http://schemas.microsoft.com/office/drawing/2014/main" id="{DA18D6B2-6BE5-4AD7-A5CB-E3E7BB1A4BBD}"/>
-              </a:ext>
-            </a:extLst>
-          </p:cNvPr>
-          <p:cNvSpPr>
-            <a:spLocks xmlns:a="http://schemas.openxmlformats.org/drawingml/2006/main" noGrp="1"/>
-          </p:cNvSpPr>
-          <p:nvPr/>
-        </p:nvSpPr>
-        <p:spPr>
-          <a:xfrm xmlns:a="http://schemas.openxmlformats.org/drawingml/2006/main">
-            <a:off x="9086850" y="4095750"/>
-            <a:ext cx="1790700" cy="361950"/>
+          <p:cNvPr id="20" name="problem-text-4">
+            <a:extLst xmlns:a="http://schemas.openxmlformats.org/drawingml/2006/main">
+              <a:ext uri="{FF2B5EF4-FFF2-40B4-BE49-F238E27FC236}">
+                <a16:creationId xmlns:a16="http://schemas.microsoft.com/office/drawing/2014/main" id="{D1664DEE-7E3D-42D1-B30D-7731B8F1DD2A}"/>
+              </a:ext>
+            </a:extLst>
+          </p:cNvPr>
+          <p:cNvSpPr>
+            <a:spLocks xmlns:a="http://schemas.openxmlformats.org/drawingml/2006/main" noGrp="1"/>
+          </p:cNvSpPr>
+          <p:nvPr/>
+        </p:nvSpPr>
+        <p:spPr>
+          <a:xfrm xmlns:a="http://schemas.openxmlformats.org/drawingml/2006/main">
+            <a:off x="9086850" y="3733800"/>
+            <a:ext cx="1905000" cy="361950"/>
           </a:xfrm>
           <a:prstGeom xmlns:a="http://schemas.openxmlformats.org/drawingml/2006/main" prst="rect">
             <a:avLst/>
@@ -2144,7 +2144,7 @@
           <a:lstStyle xmlns:a="http://schemas.openxmlformats.org/drawingml/2006/main"/>
           <a:p xmlns:a="http://schemas.openxmlformats.org/drawingml/2006/main">
             <a:pPr algn="l">
-              <a:defRPr sz="1350" b="0">
+              <a:defRPr sz="1275" b="0">
                 <a:solidFill>
                   <a:srgbClr val="FFFFFF"/>
                 </a:solidFill>
@@ -2154,7 +2154,7 @@
               </a:defRPr>
             </a:pPr>
             <a:r>
-              <a:rPr sz="1350" b="0">
+              <a:rPr sz="1275" b="0">
                 <a:solidFill>
                   <a:srgbClr val="FFFFFF"/>
                 </a:solidFill>
@@ -2162,29 +2162,172 @@
                 <a:ea typeface="Aptos"/>
                 <a:cs typeface="Aptos"/>
               </a:rPr>
-              <a:t>Teams keep working in their chosen tools</a:t>
+              <a:t>Teams burn time and tokens repeating context</a:t>
             </a:r>
           </a:p>
         </p:txBody>
       </p:sp>
       <p:sp>
         <p:nvSpPr>
-          <p:cNvPr id="21" name="cover-note">
-            <a:extLst xmlns:a="http://schemas.openxmlformats.org/drawingml/2006/main">
-              <a:ext uri="{FF2B5EF4-FFF2-40B4-BE49-F238E27FC236}">
-                <a16:creationId xmlns:a16="http://schemas.microsoft.com/office/drawing/2014/main" id="{96470507-7273-495F-8EC6-0187EE067AB2}"/>
-              </a:ext>
-            </a:extLst>
-          </p:cNvPr>
-          <p:cNvSpPr>
-            <a:spLocks xmlns:a="http://schemas.openxmlformats.org/drawingml/2006/main" noGrp="1"/>
-          </p:cNvSpPr>
-          <p:nvPr/>
-        </p:nvSpPr>
-        <p:spPr>
-          <a:xfrm xmlns:a="http://schemas.openxmlformats.org/drawingml/2006/main">
-            <a:off x="8420100" y="4781550"/>
-            <a:ext cx="2343150" cy="266700"/>
+          <p:cNvPr id="21" name="problem-dot-5">
+            <a:extLst xmlns:a="http://schemas.openxmlformats.org/drawingml/2006/main">
+              <a:ext uri="{FF2B5EF4-FFF2-40B4-BE49-F238E27FC236}">
+                <a16:creationId xmlns:a16="http://schemas.microsoft.com/office/drawing/2014/main" id="{6365F82F-037D-429E-AEF0-3F0BAC544ED4}"/>
+              </a:ext>
+            </a:extLst>
+          </p:cNvPr>
+          <p:cNvSpPr>
+            <a:spLocks xmlns:a="http://schemas.openxmlformats.org/drawingml/2006/main" noGrp="1"/>
+          </p:cNvSpPr>
+          <p:nvPr/>
+        </p:nvSpPr>
+        <p:spPr>
+          <a:xfrm xmlns:a="http://schemas.openxmlformats.org/drawingml/2006/main">
+            <a:off x="8629650" y="4305300"/>
+            <a:ext cx="285750" cy="285750"/>
+          </a:xfrm>
+          <a:prstGeom xmlns:a="http://schemas.openxmlformats.org/drawingml/2006/main" prst="ellipse">
+            <a:avLst/>
+          </a:prstGeom>
+          <a:solidFill xmlns:a="http://schemas.openxmlformats.org/drawingml/2006/main">
+            <a:srgbClr val="7C8CFF"/>
+          </a:solidFill>
+          <a:ln xmlns:a="http://schemas.openxmlformats.org/drawingml/2006/main" w="0">
+            <a:noFill/>
+            <a:prstDash val="solid"/>
+          </a:ln>
+        </p:spPr>
+      </p:sp>
+      <p:sp>
+        <p:nvSpPr>
+          <p:cNvPr id="22" name="problem-num-5">
+            <a:extLst xmlns:a="http://schemas.openxmlformats.org/drawingml/2006/main">
+              <a:ext uri="{FF2B5EF4-FFF2-40B4-BE49-F238E27FC236}">
+                <a16:creationId xmlns:a16="http://schemas.microsoft.com/office/drawing/2014/main" id="{72D6FEA8-0F08-4FE9-A207-C136DC9C38DD}"/>
+              </a:ext>
+            </a:extLst>
+          </p:cNvPr>
+          <p:cNvSpPr>
+            <a:spLocks xmlns:a="http://schemas.openxmlformats.org/drawingml/2006/main" noGrp="1"/>
+          </p:cNvSpPr>
+          <p:nvPr/>
+        </p:nvSpPr>
+        <p:spPr>
+          <a:xfrm xmlns:a="http://schemas.openxmlformats.org/drawingml/2006/main">
+            <a:off x="8705850" y="4352925"/>
+            <a:ext cx="133350" cy="171450"/>
+          </a:xfrm>
+          <a:prstGeom xmlns:a="http://schemas.openxmlformats.org/drawingml/2006/main" prst="rect">
+            <a:avLst/>
+          </a:prstGeom>
+          <a:noFill xmlns:a="http://schemas.openxmlformats.org/drawingml/2006/main"/>
+          <a:ln xmlns:a="http://schemas.openxmlformats.org/drawingml/2006/main" w="0">
+            <a:noFill/>
+            <a:prstDash val="solid"/>
+          </a:ln>
+        </p:spPr>
+        <p:txBody>
+          <a:bodyPr xmlns:a="http://schemas.openxmlformats.org/drawingml/2006/main"/>
+          <a:lstStyle xmlns:a="http://schemas.openxmlformats.org/drawingml/2006/main"/>
+          <a:p xmlns:a="http://schemas.openxmlformats.org/drawingml/2006/main">
+            <a:pPr algn="ctr">
+              <a:defRPr sz="975" b="1">
+                <a:solidFill>
+                  <a:srgbClr val="FFFFFF"/>
+                </a:solidFill>
+                <a:latin typeface="Aptos"/>
+                <a:ea typeface="Aptos"/>
+                <a:cs typeface="Aptos"/>
+              </a:defRPr>
+            </a:pPr>
+            <a:r>
+              <a:rPr sz="975" b="1">
+                <a:solidFill>
+                  <a:srgbClr val="FFFFFF"/>
+                </a:solidFill>
+                <a:latin typeface="Aptos"/>
+                <a:ea typeface="Aptos"/>
+                <a:cs typeface="Aptos"/>
+              </a:rPr>
+              <a:t>5</a:t>
+            </a:r>
+          </a:p>
+        </p:txBody>
+      </p:sp>
+      <p:sp>
+        <p:nvSpPr>
+          <p:cNvPr id="23" name="problem-text-5">
+            <a:extLst xmlns:a="http://schemas.openxmlformats.org/drawingml/2006/main">
+              <a:ext uri="{FF2B5EF4-FFF2-40B4-BE49-F238E27FC236}">
+                <a16:creationId xmlns:a16="http://schemas.microsoft.com/office/drawing/2014/main" id="{1CCC0B7E-7820-464E-B8E9-62CC12C23700}"/>
+              </a:ext>
+            </a:extLst>
+          </p:cNvPr>
+          <p:cNvSpPr>
+            <a:spLocks xmlns:a="http://schemas.openxmlformats.org/drawingml/2006/main" noGrp="1"/>
+          </p:cNvSpPr>
+          <p:nvPr/>
+        </p:nvSpPr>
+        <p:spPr>
+          <a:xfrm xmlns:a="http://schemas.openxmlformats.org/drawingml/2006/main">
+            <a:off x="9086850" y="4286250"/>
+            <a:ext cx="1905000" cy="361950"/>
+          </a:xfrm>
+          <a:prstGeom xmlns:a="http://schemas.openxmlformats.org/drawingml/2006/main" prst="rect">
+            <a:avLst/>
+          </a:prstGeom>
+          <a:noFill xmlns:a="http://schemas.openxmlformats.org/drawingml/2006/main"/>
+          <a:ln xmlns:a="http://schemas.openxmlformats.org/drawingml/2006/main" w="0">
+            <a:noFill/>
+            <a:prstDash val="solid"/>
+          </a:ln>
+        </p:spPr>
+        <p:txBody>
+          <a:bodyPr xmlns:a="http://schemas.openxmlformats.org/drawingml/2006/main"/>
+          <a:lstStyle xmlns:a="http://schemas.openxmlformats.org/drawingml/2006/main"/>
+          <a:p xmlns:a="http://schemas.openxmlformats.org/drawingml/2006/main">
+            <a:pPr algn="l">
+              <a:defRPr sz="1275" b="0">
+                <a:solidFill>
+                  <a:srgbClr val="FFFFFF"/>
+                </a:solidFill>
+                <a:latin typeface="Aptos"/>
+                <a:ea typeface="Aptos"/>
+                <a:cs typeface="Aptos"/>
+              </a:defRPr>
+            </a:pPr>
+            <a:r>
+              <a:rPr sz="1275" b="0">
+                <a:solidFill>
+                  <a:srgbClr val="FFFFFF"/>
+                </a:solidFill>
+                <a:latin typeface="Aptos"/>
+                <a:ea typeface="Aptos"/>
+                <a:cs typeface="Aptos"/>
+              </a:rPr>
+              <a:t>Code drifts from product conventions</a:t>
+            </a:r>
+          </a:p>
+        </p:txBody>
+      </p:sp>
+      <p:sp>
+        <p:nvSpPr>
+          <p:cNvPr id="24" name="problem-note">
+            <a:extLst xmlns:a="http://schemas.openxmlformats.org/drawingml/2006/main">
+              <a:ext uri="{FF2B5EF4-FFF2-40B4-BE49-F238E27FC236}">
+                <a16:creationId xmlns:a16="http://schemas.microsoft.com/office/drawing/2014/main" id="{AB8588F3-2BC3-4B98-9E18-2D76425AF00A}"/>
+              </a:ext>
+            </a:extLst>
+          </p:cNvPr>
+          <p:cNvSpPr>
+            <a:spLocks xmlns:a="http://schemas.openxmlformats.org/drawingml/2006/main" noGrp="1"/>
+          </p:cNvSpPr>
+          <p:nvPr/>
+        </p:nvSpPr>
+        <p:spPr>
+          <a:xfrm xmlns:a="http://schemas.openxmlformats.org/drawingml/2006/main">
+            <a:off x="8420100" y="5048250"/>
+            <a:ext cx="2381250" cy="266700"/>
           </a:xfrm>
           <a:prstGeom xmlns:a="http://schemas.openxmlformats.org/drawingml/2006/main" prst="rect">
             <a:avLst/>
@@ -2218,17 +2361,17 @@
                 <a:ea typeface="Aptos"/>
                 <a:cs typeface="Aptos"/>
               </a:rPr>
-              <a:t>Built for business confidence, not AI guesswork.</a:t>
+              <a:t>The issue is not AI capability. It is missing product context.</a:t>
             </a:r>
           </a:p>
         </p:txBody>
       </p:sp>
       <p:sp>
         <p:nvSpPr>
-          <p:cNvPr id="22" name="cover-footer">
-            <a:extLst xmlns:a="http://schemas.openxmlformats.org/drawingml/2006/main">
-              <a:ext uri="{FF2B5EF4-FFF2-40B4-BE49-F238E27FC236}">
-                <a16:creationId xmlns:a16="http://schemas.microsoft.com/office/drawing/2014/main" id="{4B87C5A7-5FDD-40D3-B492-E7582AF99FF4}"/>
+          <p:cNvPr id="25" name="cover-footer">
+            <a:extLst xmlns:a="http://schemas.openxmlformats.org/drawingml/2006/main">
+              <a:ext uri="{FF2B5EF4-FFF2-40B4-BE49-F238E27FC236}">
+                <a16:creationId xmlns:a16="http://schemas.microsoft.com/office/drawing/2014/main" id="{91676E9B-EBFA-4C02-8D84-7F70B823E7E6}"/>
               </a:ext>
             </a:extLst>
           </p:cNvPr>
@@ -2282,7 +2425,7 @@
     </p:spTree>
     <p:extLst>
       <p:ext uri="{BB962C8B-B14F-4D97-AF65-F5344CB8AC3E}">
-        <p14:creationId xmlns:p14="http://schemas.microsoft.com/office/powerpoint/2010/main" val="1930029814"/>
+        <p14:creationId xmlns:p14="http://schemas.microsoft.com/office/powerpoint/2010/main" val="912206873"/>
       </p:ext>
     </p:extLst>
   </p:cSld>
@@ -2313,7 +2456,7 @@
           <p:cNvPr id="1" name="brand-mark">
             <a:extLst xmlns:a="http://schemas.openxmlformats.org/drawingml/2006/main">
               <a:ext uri="{FF2B5EF4-FFF2-40B4-BE49-F238E27FC236}">
-                <a16:creationId xmlns:a16="http://schemas.microsoft.com/office/drawing/2014/main" id="{4C27AE05-A8E4-4802-B6FC-46F550B88081}"/>
+                <a16:creationId xmlns:a16="http://schemas.microsoft.com/office/drawing/2014/main" id="{7C41CE66-E880-4882-9C84-096F3EF7DD68}"/>
               </a:ext>
             </a:extLst>
           </p:cNvPr>
@@ -2346,7 +2489,7 @@
           <p:cNvPr id="2" name="brand-word">
             <a:extLst xmlns:a="http://schemas.openxmlformats.org/drawingml/2006/main">
               <a:ext uri="{FF2B5EF4-FFF2-40B4-BE49-F238E27FC236}">
-                <a16:creationId xmlns:a16="http://schemas.microsoft.com/office/drawing/2014/main" id="{80F3E447-87F1-4295-B833-965302A2D4D1}"/>
+                <a16:creationId xmlns:a16="http://schemas.microsoft.com/office/drawing/2014/main" id="{97B0D893-7191-46F5-BDE8-3864D73E28A2}"/>
               </a:ext>
             </a:extLst>
           </p:cNvPr>
@@ -2402,19 +2545,19 @@
           <p:cNvPr id="3" name="title">
             <a:extLst xmlns:a="http://schemas.openxmlformats.org/drawingml/2006/main">
               <a:ext uri="{FF2B5EF4-FFF2-40B4-BE49-F238E27FC236}">
-                <a16:creationId xmlns:a16="http://schemas.microsoft.com/office/drawing/2014/main" id="{B085CBBF-6C21-498B-A355-B4B40E298775}"/>
-              </a:ext>
-            </a:extLst>
-          </p:cNvPr>
-          <p:cNvSpPr>
-            <a:spLocks xmlns:a="http://schemas.openxmlformats.org/drawingml/2006/main" noGrp="1"/>
-          </p:cNvSpPr>
-          <p:nvPr/>
-        </p:nvSpPr>
-        <p:spPr>
-          <a:xfrm xmlns:a="http://schemas.openxmlformats.org/drawingml/2006/main">
-            <a:off x="685800" y="1123950"/>
-            <a:ext cx="5905500" cy="514350"/>
+                <a16:creationId xmlns:a16="http://schemas.microsoft.com/office/drawing/2014/main" id="{58824B71-8129-4CB4-8DA8-B75957519293}"/>
+              </a:ext>
+            </a:extLst>
+          </p:cNvPr>
+          <p:cNvSpPr>
+            <a:spLocks xmlns:a="http://schemas.openxmlformats.org/drawingml/2006/main" noGrp="1"/>
+          </p:cNvSpPr>
+          <p:nvPr/>
+        </p:nvSpPr>
+        <p:spPr>
+          <a:xfrm xmlns:a="http://schemas.openxmlformats.org/drawingml/2006/main">
+            <a:off x="685800" y="1028700"/>
+            <a:ext cx="7048500" cy="514350"/>
           </a:xfrm>
           <a:prstGeom xmlns:a="http://schemas.openxmlformats.org/drawingml/2006/main" prst="rect">
             <a:avLst/>
@@ -2448,7 +2591,7 @@
                 <a:ea typeface="Aptos Display"/>
                 <a:cs typeface="Aptos Display"/>
               </a:rPr>
-              <a:t>The demo story in one view</a:t>
+              <a:t>Nexus makes AI product-grounded</a:t>
             </a:r>
           </a:p>
         </p:txBody>
@@ -2458,19 +2601,19 @@
           <p:cNvPr id="4" name="subtitle">
             <a:extLst xmlns:a="http://schemas.openxmlformats.org/drawingml/2006/main">
               <a:ext uri="{FF2B5EF4-FFF2-40B4-BE49-F238E27FC236}">
-                <a16:creationId xmlns:a16="http://schemas.microsoft.com/office/drawing/2014/main" id="{FD797073-85B1-4A1F-BD37-BAD7834306A2}"/>
-              </a:ext>
-            </a:extLst>
-          </p:cNvPr>
-          <p:cNvSpPr>
-            <a:spLocks xmlns:a="http://schemas.openxmlformats.org/drawingml/2006/main" noGrp="1"/>
-          </p:cNvSpPr>
-          <p:nvPr/>
-        </p:nvSpPr>
-        <p:spPr>
-          <a:xfrm xmlns:a="http://schemas.openxmlformats.org/drawingml/2006/main">
-            <a:off x="704850" y="1695450"/>
-            <a:ext cx="7810500" cy="323850"/>
+                <a16:creationId xmlns:a16="http://schemas.microsoft.com/office/drawing/2014/main" id="{C75B7A96-AF2A-4B95-ADB8-64A16163352E}"/>
+              </a:ext>
+            </a:extLst>
+          </p:cNvPr>
+          <p:cNvSpPr>
+            <a:spLocks xmlns:a="http://schemas.openxmlformats.org/drawingml/2006/main" noGrp="1"/>
+          </p:cNvSpPr>
+          <p:nvPr/>
+        </p:nvSpPr>
+        <p:spPr>
+          <a:xfrm xmlns:a="http://schemas.openxmlformats.org/drawingml/2006/main">
+            <a:off x="704850" y="1600200"/>
+            <a:ext cx="8477250" cy="323850"/>
           </a:xfrm>
           <a:prstGeom xmlns:a="http://schemas.openxmlformats.org/drawingml/2006/main" prst="rect">
             <a:avLst/>
@@ -2504,33 +2647,33 @@
                 <a:ea typeface="Aptos"/>
                 <a:cs typeface="Aptos"/>
               </a:rPr>
-              <a:t>From scattered knowledge to approved AI guidance, without changing where teams work.</a:t>
+              <a:t>The business proposition: give every team and every AI tool the same reusable product context.</a:t>
             </a:r>
           </a:p>
         </p:txBody>
       </p:sp>
       <p:sp>
         <p:nvSpPr>
-          <p:cNvPr id="5" name="story-step-1">
-            <a:extLst xmlns:a="http://schemas.openxmlformats.org/drawingml/2006/main">
-              <a:ext uri="{FF2B5EF4-FFF2-40B4-BE49-F238E27FC236}">
-                <a16:creationId xmlns:a16="http://schemas.microsoft.com/office/drawing/2014/main" id="{5D7EBFE7-4DC8-41E2-8109-1A4A3B913E34}"/>
-              </a:ext>
-            </a:extLst>
-          </p:cNvPr>
-          <p:cNvSpPr>
-            <a:spLocks xmlns:a="http://schemas.openxmlformats.org/drawingml/2006/main" noGrp="1"/>
-          </p:cNvSpPr>
-          <p:nvPr/>
-        </p:nvSpPr>
-        <p:spPr>
-          <a:xfrm xmlns:a="http://schemas.openxmlformats.org/drawingml/2006/main">
-            <a:off x="1009650" y="2724150"/>
-            <a:ext cx="2705100" cy="1466850"/>
+          <p:cNvPr id="5" name="prop-card-1">
+            <a:extLst xmlns:a="http://schemas.openxmlformats.org/drawingml/2006/main">
+              <a:ext uri="{FF2B5EF4-FFF2-40B4-BE49-F238E27FC236}">
+                <a16:creationId xmlns:a16="http://schemas.microsoft.com/office/drawing/2014/main" id="{59C73558-83C4-4EE9-B871-68C63CABA598}"/>
+              </a:ext>
+            </a:extLst>
+          </p:cNvPr>
+          <p:cNvSpPr>
+            <a:spLocks xmlns:a="http://schemas.openxmlformats.org/drawingml/2006/main" noGrp="1"/>
+          </p:cNvSpPr>
+          <p:nvPr/>
+        </p:nvSpPr>
+        <p:spPr>
+          <a:xfrm xmlns:a="http://schemas.openxmlformats.org/drawingml/2006/main">
+            <a:off x="781050" y="2381250"/>
+            <a:ext cx="4762500" cy="1009650"/>
           </a:xfrm>
           <a:prstGeom xmlns:a="http://schemas.openxmlformats.org/drawingml/2006/main" prst="roundRect">
             <a:avLst>
-              <a:gd name="adj" fmla="val 7792"/>
+              <a:gd name="adj" fmla="val 11321"/>
             </a:avLst>
           </a:prstGeom>
           <a:solidFill xmlns:a="http://schemas.openxmlformats.org/drawingml/2006/main">
@@ -2546,22 +2689,22 @@
       </p:sp>
       <p:sp>
         <p:nvSpPr>
-          <p:cNvPr id="6" name="story-icon-1">
-            <a:extLst xmlns:a="http://schemas.openxmlformats.org/drawingml/2006/main">
-              <a:ext uri="{FF2B5EF4-FFF2-40B4-BE49-F238E27FC236}">
-                <a16:creationId xmlns:a16="http://schemas.microsoft.com/office/drawing/2014/main" id="{508DA1D6-2CE0-45FC-B617-C80B0B6C74EA}"/>
-              </a:ext>
-            </a:extLst>
-          </p:cNvPr>
-          <p:cNvSpPr>
-            <a:spLocks xmlns:a="http://schemas.openxmlformats.org/drawingml/2006/main" noGrp="1"/>
-          </p:cNvSpPr>
-          <p:nvPr/>
-        </p:nvSpPr>
-        <p:spPr>
-          <a:xfrm xmlns:a="http://schemas.openxmlformats.org/drawingml/2006/main">
-            <a:off x="1276350" y="2990850"/>
-            <a:ext cx="419100" cy="419100"/>
+          <p:cNvPr id="6" name="prop-icon-1">
+            <a:extLst xmlns:a="http://schemas.openxmlformats.org/drawingml/2006/main">
+              <a:ext uri="{FF2B5EF4-FFF2-40B4-BE49-F238E27FC236}">
+                <a16:creationId xmlns:a16="http://schemas.microsoft.com/office/drawing/2014/main" id="{9A8F3730-DF23-415C-A404-285EDBA254D2}"/>
+              </a:ext>
+            </a:extLst>
+          </p:cNvPr>
+          <p:cNvSpPr>
+            <a:spLocks xmlns:a="http://schemas.openxmlformats.org/drawingml/2006/main" noGrp="1"/>
+          </p:cNvSpPr>
+          <p:nvPr/>
+        </p:nvSpPr>
+        <p:spPr>
+          <a:xfrm xmlns:a="http://schemas.openxmlformats.org/drawingml/2006/main">
+            <a:off x="1028700" y="2609850"/>
+            <a:ext cx="342900" cy="342900"/>
           </a:xfrm>
           <a:prstGeom xmlns:a="http://schemas.openxmlformats.org/drawingml/2006/main" prst="ellipse">
             <a:avLst/>
@@ -2577,22 +2720,22 @@
       </p:sp>
       <p:sp>
         <p:nvSpPr>
-          <p:cNvPr id="7" name="story-num-1">
-            <a:extLst xmlns:a="http://schemas.openxmlformats.org/drawingml/2006/main">
-              <a:ext uri="{FF2B5EF4-FFF2-40B4-BE49-F238E27FC236}">
-                <a16:creationId xmlns:a16="http://schemas.microsoft.com/office/drawing/2014/main" id="{FE26EF3C-4761-4887-A1BE-6A678E03C8B0}"/>
-              </a:ext>
-            </a:extLst>
-          </p:cNvPr>
-          <p:cNvSpPr>
-            <a:spLocks xmlns:a="http://schemas.openxmlformats.org/drawingml/2006/main" noGrp="1"/>
-          </p:cNvSpPr>
-          <p:nvPr/>
-        </p:nvSpPr>
-        <p:spPr>
-          <a:xfrm xmlns:a="http://schemas.openxmlformats.org/drawingml/2006/main">
-            <a:off x="1409700" y="3086100"/>
-            <a:ext cx="152400" cy="190500"/>
+          <p:cNvPr id="7" name="prop-num-1">
+            <a:extLst xmlns:a="http://schemas.openxmlformats.org/drawingml/2006/main">
+              <a:ext uri="{FF2B5EF4-FFF2-40B4-BE49-F238E27FC236}">
+                <a16:creationId xmlns:a16="http://schemas.microsoft.com/office/drawing/2014/main" id="{7FA64CE9-E5C8-4673-8785-5FD00786B221}"/>
+              </a:ext>
+            </a:extLst>
+          </p:cNvPr>
+          <p:cNvSpPr>
+            <a:spLocks xmlns:a="http://schemas.openxmlformats.org/drawingml/2006/main" noGrp="1"/>
+          </p:cNvSpPr>
+          <p:nvPr/>
+        </p:nvSpPr>
+        <p:spPr>
+          <a:xfrm xmlns:a="http://schemas.openxmlformats.org/drawingml/2006/main">
+            <a:off x="1143000" y="2686050"/>
+            <a:ext cx="114300" cy="152400"/>
           </a:xfrm>
           <a:prstGeom xmlns:a="http://schemas.openxmlformats.org/drawingml/2006/main" prst="rect">
             <a:avLst/>
@@ -2608,7 +2751,7 @@
           <a:lstStyle xmlns:a="http://schemas.openxmlformats.org/drawingml/2006/main"/>
           <a:p xmlns:a="http://schemas.openxmlformats.org/drawingml/2006/main">
             <a:pPr algn="ctr">
-              <a:defRPr sz="1200" b="1">
+              <a:defRPr sz="975" b="1">
                 <a:solidFill>
                   <a:srgbClr val="FFFFFF"/>
                 </a:solidFill>
@@ -2618,7 +2761,7 @@
               </a:defRPr>
             </a:pPr>
             <a:r>
-              <a:rPr sz="1200" b="1">
+              <a:rPr sz="975" b="1">
                 <a:solidFill>
                   <a:srgbClr val="FFFFFF"/>
                 </a:solidFill>
@@ -2633,22 +2776,22 @@
       </p:sp>
       <p:sp>
         <p:nvSpPr>
-          <p:cNvPr id="8" name="story-heading-1">
-            <a:extLst xmlns:a="http://schemas.openxmlformats.org/drawingml/2006/main">
-              <a:ext uri="{FF2B5EF4-FFF2-40B4-BE49-F238E27FC236}">
-                <a16:creationId xmlns:a16="http://schemas.microsoft.com/office/drawing/2014/main" id="{4203B8DC-65DC-488F-B646-B3C4DB390E1E}"/>
-              </a:ext>
-            </a:extLst>
-          </p:cNvPr>
-          <p:cNvSpPr>
-            <a:spLocks xmlns:a="http://schemas.openxmlformats.org/drawingml/2006/main" noGrp="1"/>
-          </p:cNvSpPr>
-          <p:nvPr/>
-        </p:nvSpPr>
-        <p:spPr>
-          <a:xfrm xmlns:a="http://schemas.openxmlformats.org/drawingml/2006/main">
-            <a:off x="1885950" y="3028950"/>
-            <a:ext cx="1428750" cy="266700"/>
+          <p:cNvPr id="8" name="prop-heading-1">
+            <a:extLst xmlns:a="http://schemas.openxmlformats.org/drawingml/2006/main">
+              <a:ext uri="{FF2B5EF4-FFF2-40B4-BE49-F238E27FC236}">
+                <a16:creationId xmlns:a16="http://schemas.microsoft.com/office/drawing/2014/main" id="{C4390547-FB58-4D73-B73E-0F05A96C77F1}"/>
+              </a:ext>
+            </a:extLst>
+          </p:cNvPr>
+          <p:cNvSpPr>
+            <a:spLocks xmlns:a="http://schemas.openxmlformats.org/drawingml/2006/main" noGrp="1"/>
+          </p:cNvSpPr>
+          <p:nvPr/>
+        </p:nvSpPr>
+        <p:spPr>
+          <a:xfrm xmlns:a="http://schemas.openxmlformats.org/drawingml/2006/main">
+            <a:off x="1524000" y="2571750"/>
+            <a:ext cx="3714750" cy="247650"/>
           </a:xfrm>
           <a:prstGeom xmlns:a="http://schemas.openxmlformats.org/drawingml/2006/main" prst="rect">
             <a:avLst/>
@@ -2664,7 +2807,7 @@
           <a:lstStyle xmlns:a="http://schemas.openxmlformats.org/drawingml/2006/main"/>
           <a:p xmlns:a="http://schemas.openxmlformats.org/drawingml/2006/main">
             <a:pPr algn="l">
-              <a:defRPr sz="1875" b="1">
+              <a:defRPr sz="1725" b="1">
                 <a:solidFill>
                   <a:srgbClr val="12121A"/>
                 </a:solidFill>
@@ -2674,7 +2817,7 @@
               </a:defRPr>
             </a:pPr>
             <a:r>
-              <a:rPr sz="1875" b="1">
+              <a:rPr sz="1725" b="1">
                 <a:solidFill>
                   <a:srgbClr val="12121A"/>
                 </a:solidFill>
@@ -2682,29 +2825,29 @@
                 <a:ea typeface="Aptos"/>
                 <a:cs typeface="Aptos"/>
               </a:rPr>
-              <a:t>Connect</a:t>
+              <a:t>Easier onboarding</a:t>
             </a:r>
           </a:p>
         </p:txBody>
       </p:sp>
       <p:sp>
         <p:nvSpPr>
-          <p:cNvPr id="9" name="story-body-1">
-            <a:extLst xmlns:a="http://schemas.openxmlformats.org/drawingml/2006/main">
-              <a:ext uri="{FF2B5EF4-FFF2-40B4-BE49-F238E27FC236}">
-                <a16:creationId xmlns:a16="http://schemas.microsoft.com/office/drawing/2014/main" id="{F7E035BA-6CDA-4D28-97B4-B0ED9CD19CF9}"/>
-              </a:ext>
-            </a:extLst>
-          </p:cNvPr>
-          <p:cNvSpPr>
-            <a:spLocks xmlns:a="http://schemas.openxmlformats.org/drawingml/2006/main" noGrp="1"/>
-          </p:cNvSpPr>
-          <p:nvPr/>
-        </p:nvSpPr>
-        <p:spPr>
-          <a:xfrm xmlns:a="http://schemas.openxmlformats.org/drawingml/2006/main">
-            <a:off x="1295400" y="3562350"/>
-            <a:ext cx="2095500" cy="400050"/>
+          <p:cNvPr id="9" name="prop-body-1">
+            <a:extLst xmlns:a="http://schemas.openxmlformats.org/drawingml/2006/main">
+              <a:ext uri="{FF2B5EF4-FFF2-40B4-BE49-F238E27FC236}">
+                <a16:creationId xmlns:a16="http://schemas.microsoft.com/office/drawing/2014/main" id="{0E6DA0FB-7E0A-491C-9AD4-81161BF27D9F}"/>
+              </a:ext>
+            </a:extLst>
+          </p:cNvPr>
+          <p:cNvSpPr>
+            <a:spLocks xmlns:a="http://schemas.openxmlformats.org/drawingml/2006/main" noGrp="1"/>
+          </p:cNvSpPr>
+          <p:nvPr/>
+        </p:nvSpPr>
+        <p:spPr>
+          <a:xfrm xmlns:a="http://schemas.openxmlformats.org/drawingml/2006/main">
+            <a:off x="1524000" y="2895600"/>
+            <a:ext cx="3695700" cy="361950"/>
           </a:xfrm>
           <a:prstGeom xmlns:a="http://schemas.openxmlformats.org/drawingml/2006/main" prst="rect">
             <a:avLst/>
@@ -2720,7 +2863,7 @@
           <a:lstStyle xmlns:a="http://schemas.openxmlformats.org/drawingml/2006/main"/>
           <a:p xmlns:a="http://schemas.openxmlformats.org/drawingml/2006/main">
             <a:pPr algn="l">
-              <a:defRPr sz="1350" b="0">
+              <a:defRPr sz="1275" b="0">
                 <a:solidFill>
                   <a:srgbClr val="5E6472"/>
                 </a:solidFill>
@@ -2730,7 +2873,7 @@
               </a:defRPr>
             </a:pPr>
             <a:r>
-              <a:rPr sz="1350" b="0">
+              <a:rPr sz="1275" b="0">
                 <a:solidFill>
                   <a:srgbClr val="5E6472"/>
                 </a:solidFill>
@@ -2738,29 +2881,95 @@
                 <a:ea typeface="Aptos"/>
                 <a:cs typeface="Aptos"/>
               </a:rPr>
-              <a:t>Bring the product’s knowledge together.</a:t>
+              <a:t>New engineers start with product rules, vocabulary, and decisions already packaged.</a:t>
             </a:r>
           </a:p>
         </p:txBody>
       </p:sp>
       <p:sp>
         <p:nvSpPr>
-          <p:cNvPr id="10" name="story-arrow-1">
-            <a:extLst xmlns:a="http://schemas.openxmlformats.org/drawingml/2006/main">
-              <a:ext uri="{FF2B5EF4-FFF2-40B4-BE49-F238E27FC236}">
-                <a16:creationId xmlns:a16="http://schemas.microsoft.com/office/drawing/2014/main" id="{D47C3F5A-5E8D-41B5-8D93-827D04589406}"/>
-              </a:ext>
-            </a:extLst>
-          </p:cNvPr>
-          <p:cNvSpPr>
-            <a:spLocks xmlns:a="http://schemas.openxmlformats.org/drawingml/2006/main" noGrp="1"/>
-          </p:cNvSpPr>
-          <p:nvPr/>
-        </p:nvSpPr>
-        <p:spPr>
-          <a:xfrm xmlns:a="http://schemas.openxmlformats.org/drawingml/2006/main">
-            <a:off x="3886200" y="3257550"/>
-            <a:ext cx="342900" cy="323850"/>
+          <p:cNvPr id="10" name="prop-card-2">
+            <a:extLst xmlns:a="http://schemas.openxmlformats.org/drawingml/2006/main">
+              <a:ext uri="{FF2B5EF4-FFF2-40B4-BE49-F238E27FC236}">
+                <a16:creationId xmlns:a16="http://schemas.microsoft.com/office/drawing/2014/main" id="{5D72E629-6BE1-4205-B872-24339F44F51B}"/>
+              </a:ext>
+            </a:extLst>
+          </p:cNvPr>
+          <p:cNvSpPr>
+            <a:spLocks xmlns:a="http://schemas.openxmlformats.org/drawingml/2006/main" noGrp="1"/>
+          </p:cNvSpPr>
+          <p:nvPr/>
+        </p:nvSpPr>
+        <p:spPr>
+          <a:xfrm xmlns:a="http://schemas.openxmlformats.org/drawingml/2006/main">
+            <a:off x="6305550" y="2381250"/>
+            <a:ext cx="4762500" cy="1009650"/>
+          </a:xfrm>
+          <a:prstGeom xmlns:a="http://schemas.openxmlformats.org/drawingml/2006/main" prst="roundRect">
+            <a:avLst>
+              <a:gd name="adj" fmla="val 11321"/>
+            </a:avLst>
+          </a:prstGeom>
+          <a:solidFill xmlns:a="http://schemas.openxmlformats.org/drawingml/2006/main">
+            <a:srgbClr val="FFFFFF"/>
+          </a:solidFill>
+          <a:ln xmlns:a="http://schemas.openxmlformats.org/drawingml/2006/main" w="9525">
+            <a:solidFill>
+              <a:srgbClr val="D8DDF2"/>
+            </a:solidFill>
+            <a:prstDash val="solid"/>
+          </a:ln>
+        </p:spPr>
+      </p:sp>
+      <p:sp>
+        <p:nvSpPr>
+          <p:cNvPr id="11" name="prop-icon-2">
+            <a:extLst xmlns:a="http://schemas.openxmlformats.org/drawingml/2006/main">
+              <a:ext uri="{FF2B5EF4-FFF2-40B4-BE49-F238E27FC236}">
+                <a16:creationId xmlns:a16="http://schemas.microsoft.com/office/drawing/2014/main" id="{080FE437-33C9-4562-91FC-E9916C874DCC}"/>
+              </a:ext>
+            </a:extLst>
+          </p:cNvPr>
+          <p:cNvSpPr>
+            <a:spLocks xmlns:a="http://schemas.openxmlformats.org/drawingml/2006/main" noGrp="1"/>
+          </p:cNvSpPr>
+          <p:nvPr/>
+        </p:nvSpPr>
+        <p:spPr>
+          <a:xfrm xmlns:a="http://schemas.openxmlformats.org/drawingml/2006/main">
+            <a:off x="6553200" y="2609850"/>
+            <a:ext cx="342900" cy="342900"/>
+          </a:xfrm>
+          <a:prstGeom xmlns:a="http://schemas.openxmlformats.org/drawingml/2006/main" prst="ellipse">
+            <a:avLst/>
+          </a:prstGeom>
+          <a:solidFill xmlns:a="http://schemas.openxmlformats.org/drawingml/2006/main">
+            <a:srgbClr val="7C8CFF"/>
+          </a:solidFill>
+          <a:ln xmlns:a="http://schemas.openxmlformats.org/drawingml/2006/main" w="0">
+            <a:noFill/>
+            <a:prstDash val="solid"/>
+          </a:ln>
+        </p:spPr>
+      </p:sp>
+      <p:sp>
+        <p:nvSpPr>
+          <p:cNvPr id="12" name="prop-num-2">
+            <a:extLst xmlns:a="http://schemas.openxmlformats.org/drawingml/2006/main">
+              <a:ext uri="{FF2B5EF4-FFF2-40B4-BE49-F238E27FC236}">
+                <a16:creationId xmlns:a16="http://schemas.microsoft.com/office/drawing/2014/main" id="{3678CCD9-AE5D-46B4-B7B5-105EADE54B5D}"/>
+              </a:ext>
+            </a:extLst>
+          </p:cNvPr>
+          <p:cNvSpPr>
+            <a:spLocks xmlns:a="http://schemas.openxmlformats.org/drawingml/2006/main" noGrp="1"/>
+          </p:cNvSpPr>
+          <p:nvPr/>
+        </p:nvSpPr>
+        <p:spPr>
+          <a:xfrm xmlns:a="http://schemas.openxmlformats.org/drawingml/2006/main">
+            <a:off x="6667500" y="2686050"/>
+            <a:ext cx="114300" cy="152400"/>
           </a:xfrm>
           <a:prstGeom xmlns:a="http://schemas.openxmlformats.org/drawingml/2006/main" prst="rect">
             <a:avLst/>
@@ -2776,9 +2985,9 @@
           <a:lstStyle xmlns:a="http://schemas.openxmlformats.org/drawingml/2006/main"/>
           <a:p xmlns:a="http://schemas.openxmlformats.org/drawingml/2006/main">
             <a:pPr algn="ctr">
-              <a:defRPr sz="2250" b="1">
-                <a:solidFill>
-                  <a:srgbClr val="7C8CFF"/>
+              <a:defRPr sz="975" b="1">
+                <a:solidFill>
+                  <a:srgbClr val="FFFFFF"/>
                 </a:solidFill>
                 <a:latin typeface="Aptos"/>
                 <a:ea typeface="Aptos"/>
@@ -2786,41 +2995,153 @@
               </a:defRPr>
             </a:pPr>
             <a:r>
-              <a:rPr sz="2250" b="1">
-                <a:solidFill>
-                  <a:srgbClr val="7C8CFF"/>
+              <a:rPr sz="975" b="1">
+                <a:solidFill>
+                  <a:srgbClr val="FFFFFF"/>
                 </a:solidFill>
                 <a:latin typeface="Aptos"/>
                 <a:ea typeface="Aptos"/>
                 <a:cs typeface="Aptos"/>
               </a:rPr>
-              <a:t>→</a:t>
+              <a:t>2</a:t>
             </a:r>
           </a:p>
         </p:txBody>
       </p:sp>
       <p:sp>
         <p:nvSpPr>
-          <p:cNvPr id="11" name="story-step-2">
-            <a:extLst xmlns:a="http://schemas.openxmlformats.org/drawingml/2006/main">
-              <a:ext uri="{FF2B5EF4-FFF2-40B4-BE49-F238E27FC236}">
-                <a16:creationId xmlns:a16="http://schemas.microsoft.com/office/drawing/2014/main" id="{F1BB1D8F-C267-4F48-A4CF-7640D68F22AD}"/>
-              </a:ext>
-            </a:extLst>
-          </p:cNvPr>
-          <p:cNvSpPr>
-            <a:spLocks xmlns:a="http://schemas.openxmlformats.org/drawingml/2006/main" noGrp="1"/>
-          </p:cNvSpPr>
-          <p:nvPr/>
-        </p:nvSpPr>
-        <p:spPr>
-          <a:xfrm xmlns:a="http://schemas.openxmlformats.org/drawingml/2006/main">
-            <a:off x="4400550" y="2724150"/>
-            <a:ext cx="2705100" cy="1466850"/>
+          <p:cNvPr id="13" name="prop-heading-2">
+            <a:extLst xmlns:a="http://schemas.openxmlformats.org/drawingml/2006/main">
+              <a:ext uri="{FF2B5EF4-FFF2-40B4-BE49-F238E27FC236}">
+                <a16:creationId xmlns:a16="http://schemas.microsoft.com/office/drawing/2014/main" id="{F17A5C70-6E72-458B-AA9A-16F2758CC583}"/>
+              </a:ext>
+            </a:extLst>
+          </p:cNvPr>
+          <p:cNvSpPr>
+            <a:spLocks xmlns:a="http://schemas.openxmlformats.org/drawingml/2006/main" noGrp="1"/>
+          </p:cNvSpPr>
+          <p:nvPr/>
+        </p:nvSpPr>
+        <p:spPr>
+          <a:xfrm xmlns:a="http://schemas.openxmlformats.org/drawingml/2006/main">
+            <a:off x="7048500" y="2571750"/>
+            <a:ext cx="3714750" cy="247650"/>
+          </a:xfrm>
+          <a:prstGeom xmlns:a="http://schemas.openxmlformats.org/drawingml/2006/main" prst="rect">
+            <a:avLst/>
+          </a:prstGeom>
+          <a:noFill xmlns:a="http://schemas.openxmlformats.org/drawingml/2006/main"/>
+          <a:ln xmlns:a="http://schemas.openxmlformats.org/drawingml/2006/main" w="0">
+            <a:noFill/>
+            <a:prstDash val="solid"/>
+          </a:ln>
+        </p:spPr>
+        <p:txBody>
+          <a:bodyPr xmlns:a="http://schemas.openxmlformats.org/drawingml/2006/main"/>
+          <a:lstStyle xmlns:a="http://schemas.openxmlformats.org/drawingml/2006/main"/>
+          <a:p xmlns:a="http://schemas.openxmlformats.org/drawingml/2006/main">
+            <a:pPr algn="l">
+              <a:defRPr sz="1725" b="1">
+                <a:solidFill>
+                  <a:srgbClr val="12121A"/>
+                </a:solidFill>
+                <a:latin typeface="Aptos"/>
+                <a:ea typeface="Aptos"/>
+                <a:cs typeface="Aptos"/>
+              </a:defRPr>
+            </a:pPr>
+            <a:r>
+              <a:rPr sz="1725" b="1">
+                <a:solidFill>
+                  <a:srgbClr val="12121A"/>
+                </a:solidFill>
+                <a:latin typeface="Aptos"/>
+                <a:ea typeface="Aptos"/>
+                <a:cs typeface="Aptos"/>
+              </a:rPr>
+              <a:t>Gap identification</a:t>
+            </a:r>
+          </a:p>
+        </p:txBody>
+      </p:sp>
+      <p:sp>
+        <p:nvSpPr>
+          <p:cNvPr id="14" name="prop-body-2">
+            <a:extLst xmlns:a="http://schemas.openxmlformats.org/drawingml/2006/main">
+              <a:ext uri="{FF2B5EF4-FFF2-40B4-BE49-F238E27FC236}">
+                <a16:creationId xmlns:a16="http://schemas.microsoft.com/office/drawing/2014/main" id="{AD787850-22D8-49B6-B129-0231E2EECDCA}"/>
+              </a:ext>
+            </a:extLst>
+          </p:cNvPr>
+          <p:cNvSpPr>
+            <a:spLocks xmlns:a="http://schemas.openxmlformats.org/drawingml/2006/main" noGrp="1"/>
+          </p:cNvSpPr>
+          <p:nvPr/>
+        </p:nvSpPr>
+        <p:spPr>
+          <a:xfrm xmlns:a="http://schemas.openxmlformats.org/drawingml/2006/main">
+            <a:off x="7048500" y="2895600"/>
+            <a:ext cx="3695700" cy="361950"/>
+          </a:xfrm>
+          <a:prstGeom xmlns:a="http://schemas.openxmlformats.org/drawingml/2006/main" prst="rect">
+            <a:avLst/>
+          </a:prstGeom>
+          <a:noFill xmlns:a="http://schemas.openxmlformats.org/drawingml/2006/main"/>
+          <a:ln xmlns:a="http://schemas.openxmlformats.org/drawingml/2006/main" w="0">
+            <a:noFill/>
+            <a:prstDash val="solid"/>
+          </a:ln>
+        </p:spPr>
+        <p:txBody>
+          <a:bodyPr xmlns:a="http://schemas.openxmlformats.org/drawingml/2006/main"/>
+          <a:lstStyle xmlns:a="http://schemas.openxmlformats.org/drawingml/2006/main"/>
+          <a:p xmlns:a="http://schemas.openxmlformats.org/drawingml/2006/main">
+            <a:pPr algn="l">
+              <a:defRPr sz="1275" b="0">
+                <a:solidFill>
+                  <a:srgbClr val="5E6472"/>
+                </a:solidFill>
+                <a:latin typeface="Aptos"/>
+                <a:ea typeface="Aptos"/>
+                <a:cs typeface="Aptos"/>
+              </a:defRPr>
+            </a:pPr>
+            <a:r>
+              <a:rPr sz="1275" b="0">
+                <a:solidFill>
+                  <a:srgbClr val="5E6472"/>
+                </a:solidFill>
+                <a:latin typeface="Aptos"/>
+                <a:ea typeface="Aptos"/>
+                <a:cs typeface="Aptos"/>
+              </a:rPr>
+              <a:t>Missing docs, unclear ownership, and fuzzy conventions become visible instead of tribal.</a:t>
+            </a:r>
+          </a:p>
+        </p:txBody>
+      </p:sp>
+      <p:sp>
+        <p:nvSpPr>
+          <p:cNvPr id="15" name="prop-card-3">
+            <a:extLst xmlns:a="http://schemas.openxmlformats.org/drawingml/2006/main">
+              <a:ext uri="{FF2B5EF4-FFF2-40B4-BE49-F238E27FC236}">
+                <a16:creationId xmlns:a16="http://schemas.microsoft.com/office/drawing/2014/main" id="{5E29246A-FDA6-471D-8F91-9A2F00479C27}"/>
+              </a:ext>
+            </a:extLst>
+          </p:cNvPr>
+          <p:cNvSpPr>
+            <a:spLocks xmlns:a="http://schemas.openxmlformats.org/drawingml/2006/main" noGrp="1"/>
+          </p:cNvSpPr>
+          <p:nvPr/>
+        </p:nvSpPr>
+        <p:spPr>
+          <a:xfrm xmlns:a="http://schemas.openxmlformats.org/drawingml/2006/main">
+            <a:off x="781050" y="3695700"/>
+            <a:ext cx="4762500" cy="1009650"/>
           </a:xfrm>
           <a:prstGeom xmlns:a="http://schemas.openxmlformats.org/drawingml/2006/main" prst="roundRect">
             <a:avLst>
-              <a:gd name="adj" fmla="val 7792"/>
+              <a:gd name="adj" fmla="val 11321"/>
             </a:avLst>
           </a:prstGeom>
           <a:solidFill xmlns:a="http://schemas.openxmlformats.org/drawingml/2006/main">
@@ -2836,22 +3157,22 @@
       </p:sp>
       <p:sp>
         <p:nvSpPr>
-          <p:cNvPr id="12" name="story-icon-2">
-            <a:extLst xmlns:a="http://schemas.openxmlformats.org/drawingml/2006/main">
-              <a:ext uri="{FF2B5EF4-FFF2-40B4-BE49-F238E27FC236}">
-                <a16:creationId xmlns:a16="http://schemas.microsoft.com/office/drawing/2014/main" id="{00CC19CA-7A40-4C1D-9406-719922635952}"/>
-              </a:ext>
-            </a:extLst>
-          </p:cNvPr>
-          <p:cNvSpPr>
-            <a:spLocks xmlns:a="http://schemas.openxmlformats.org/drawingml/2006/main" noGrp="1"/>
-          </p:cNvSpPr>
-          <p:nvPr/>
-        </p:nvSpPr>
-        <p:spPr>
-          <a:xfrm xmlns:a="http://schemas.openxmlformats.org/drawingml/2006/main">
-            <a:off x="4667250" y="2990850"/>
-            <a:ext cx="419100" cy="419100"/>
+          <p:cNvPr id="16" name="prop-icon-3">
+            <a:extLst xmlns:a="http://schemas.openxmlformats.org/drawingml/2006/main">
+              <a:ext uri="{FF2B5EF4-FFF2-40B4-BE49-F238E27FC236}">
+                <a16:creationId xmlns:a16="http://schemas.microsoft.com/office/drawing/2014/main" id="{34208985-F1B7-4836-919B-12D54F0171B6}"/>
+              </a:ext>
+            </a:extLst>
+          </p:cNvPr>
+          <p:cNvSpPr>
+            <a:spLocks xmlns:a="http://schemas.openxmlformats.org/drawingml/2006/main" noGrp="1"/>
+          </p:cNvSpPr>
+          <p:nvPr/>
+        </p:nvSpPr>
+        <p:spPr>
+          <a:xfrm xmlns:a="http://schemas.openxmlformats.org/drawingml/2006/main">
+            <a:off x="1028700" y="3924300"/>
+            <a:ext cx="342900" cy="342900"/>
           </a:xfrm>
           <a:prstGeom xmlns:a="http://schemas.openxmlformats.org/drawingml/2006/main" prst="ellipse">
             <a:avLst/>
@@ -2867,22 +3188,22 @@
       </p:sp>
       <p:sp>
         <p:nvSpPr>
-          <p:cNvPr id="13" name="story-num-2">
-            <a:extLst xmlns:a="http://schemas.openxmlformats.org/drawingml/2006/main">
-              <a:ext uri="{FF2B5EF4-FFF2-40B4-BE49-F238E27FC236}">
-                <a16:creationId xmlns:a16="http://schemas.microsoft.com/office/drawing/2014/main" id="{662645C1-B2F8-4F00-86B4-7E7B54946BB3}"/>
-              </a:ext>
-            </a:extLst>
-          </p:cNvPr>
-          <p:cNvSpPr>
-            <a:spLocks xmlns:a="http://schemas.openxmlformats.org/drawingml/2006/main" noGrp="1"/>
-          </p:cNvSpPr>
-          <p:nvPr/>
-        </p:nvSpPr>
-        <p:spPr>
-          <a:xfrm xmlns:a="http://schemas.openxmlformats.org/drawingml/2006/main">
-            <a:off x="4800600" y="3086100"/>
-            <a:ext cx="152400" cy="190500"/>
+          <p:cNvPr id="17" name="prop-num-3">
+            <a:extLst xmlns:a="http://schemas.openxmlformats.org/drawingml/2006/main">
+              <a:ext uri="{FF2B5EF4-FFF2-40B4-BE49-F238E27FC236}">
+                <a16:creationId xmlns:a16="http://schemas.microsoft.com/office/drawing/2014/main" id="{3BDBF7BB-CCA4-4870-9739-93D8900448F3}"/>
+              </a:ext>
+            </a:extLst>
+          </p:cNvPr>
+          <p:cNvSpPr>
+            <a:spLocks xmlns:a="http://schemas.openxmlformats.org/drawingml/2006/main" noGrp="1"/>
+          </p:cNvSpPr>
+          <p:nvPr/>
+        </p:nvSpPr>
+        <p:spPr>
+          <a:xfrm xmlns:a="http://schemas.openxmlformats.org/drawingml/2006/main">
+            <a:off x="1143000" y="4000500"/>
+            <a:ext cx="114300" cy="152400"/>
           </a:xfrm>
           <a:prstGeom xmlns:a="http://schemas.openxmlformats.org/drawingml/2006/main" prst="rect">
             <a:avLst/>
@@ -2898,7 +3219,7 @@
           <a:lstStyle xmlns:a="http://schemas.openxmlformats.org/drawingml/2006/main"/>
           <a:p xmlns:a="http://schemas.openxmlformats.org/drawingml/2006/main">
             <a:pPr algn="ctr">
-              <a:defRPr sz="1200" b="1">
+              <a:defRPr sz="975" b="1">
                 <a:solidFill>
                   <a:srgbClr val="FFFFFF"/>
                 </a:solidFill>
@@ -2908,7 +3229,7 @@
               </a:defRPr>
             </a:pPr>
             <a:r>
-              <a:rPr sz="1200" b="1">
+              <a:rPr sz="975" b="1">
                 <a:solidFill>
                   <a:srgbClr val="FFFFFF"/>
                 </a:solidFill>
@@ -2916,29 +3237,29 @@
                 <a:ea typeface="Aptos"/>
                 <a:cs typeface="Aptos"/>
               </a:rPr>
-              <a:t>2</a:t>
+              <a:t>3</a:t>
             </a:r>
           </a:p>
         </p:txBody>
       </p:sp>
       <p:sp>
         <p:nvSpPr>
-          <p:cNvPr id="14" name="story-heading-2">
-            <a:extLst xmlns:a="http://schemas.openxmlformats.org/drawingml/2006/main">
-              <a:ext uri="{FF2B5EF4-FFF2-40B4-BE49-F238E27FC236}">
-                <a16:creationId xmlns:a16="http://schemas.microsoft.com/office/drawing/2014/main" id="{69A32417-B314-4703-B044-00A0C80E7290}"/>
-              </a:ext>
-            </a:extLst>
-          </p:cNvPr>
-          <p:cNvSpPr>
-            <a:spLocks xmlns:a="http://schemas.openxmlformats.org/drawingml/2006/main" noGrp="1"/>
-          </p:cNvSpPr>
-          <p:nvPr/>
-        </p:nvSpPr>
-        <p:spPr>
-          <a:xfrm xmlns:a="http://schemas.openxmlformats.org/drawingml/2006/main">
-            <a:off x="5276850" y="3028950"/>
-            <a:ext cx="1428750" cy="266700"/>
+          <p:cNvPr id="18" name="prop-heading-3">
+            <a:extLst xmlns:a="http://schemas.openxmlformats.org/drawingml/2006/main">
+              <a:ext uri="{FF2B5EF4-FFF2-40B4-BE49-F238E27FC236}">
+                <a16:creationId xmlns:a16="http://schemas.microsoft.com/office/drawing/2014/main" id="{02B7A329-BBD6-48C1-914C-5243F36C2091}"/>
+              </a:ext>
+            </a:extLst>
+          </p:cNvPr>
+          <p:cNvSpPr>
+            <a:spLocks xmlns:a="http://schemas.openxmlformats.org/drawingml/2006/main" noGrp="1"/>
+          </p:cNvSpPr>
+          <p:nvPr/>
+        </p:nvSpPr>
+        <p:spPr>
+          <a:xfrm xmlns:a="http://schemas.openxmlformats.org/drawingml/2006/main">
+            <a:off x="1524000" y="3886200"/>
+            <a:ext cx="3714750" cy="247650"/>
           </a:xfrm>
           <a:prstGeom xmlns:a="http://schemas.openxmlformats.org/drawingml/2006/main" prst="rect">
             <a:avLst/>
@@ -2954,7 +3275,7 @@
           <a:lstStyle xmlns:a="http://schemas.openxmlformats.org/drawingml/2006/main"/>
           <a:p xmlns:a="http://schemas.openxmlformats.org/drawingml/2006/main">
             <a:pPr algn="l">
-              <a:defRPr sz="1875" b="1">
+              <a:defRPr sz="1725" b="1">
                 <a:solidFill>
                   <a:srgbClr val="12121A"/>
                 </a:solidFill>
@@ -2964,7 +3285,7 @@
               </a:defRPr>
             </a:pPr>
             <a:r>
-              <a:rPr sz="1875" b="1">
+              <a:rPr sz="1725" b="1">
                 <a:solidFill>
                   <a:srgbClr val="12121A"/>
                 </a:solidFill>
@@ -2972,29 +3293,29 @@
                 <a:ea typeface="Aptos"/>
                 <a:cs typeface="Aptos"/>
               </a:rPr>
-              <a:t>Approve</a:t>
+              <a:t>Fewer hallucinations</a:t>
             </a:r>
           </a:p>
         </p:txBody>
       </p:sp>
       <p:sp>
         <p:nvSpPr>
-          <p:cNvPr id="15" name="story-body-2">
-            <a:extLst xmlns:a="http://schemas.openxmlformats.org/drawingml/2006/main">
-              <a:ext uri="{FF2B5EF4-FFF2-40B4-BE49-F238E27FC236}">
-                <a16:creationId xmlns:a16="http://schemas.microsoft.com/office/drawing/2014/main" id="{4E53FE52-D966-44F3-8780-3522CA1CFC66}"/>
-              </a:ext>
-            </a:extLst>
-          </p:cNvPr>
-          <p:cNvSpPr>
-            <a:spLocks xmlns:a="http://schemas.openxmlformats.org/drawingml/2006/main" noGrp="1"/>
-          </p:cNvSpPr>
-          <p:nvPr/>
-        </p:nvSpPr>
-        <p:spPr>
-          <a:xfrm xmlns:a="http://schemas.openxmlformats.org/drawingml/2006/main">
-            <a:off x="4686300" y="3562350"/>
-            <a:ext cx="2095500" cy="400050"/>
+          <p:cNvPr id="19" name="prop-body-3">
+            <a:extLst xmlns:a="http://schemas.openxmlformats.org/drawingml/2006/main">
+              <a:ext uri="{FF2B5EF4-FFF2-40B4-BE49-F238E27FC236}">
+                <a16:creationId xmlns:a16="http://schemas.microsoft.com/office/drawing/2014/main" id="{C74F4AC8-1428-408D-A079-D144BD868892}"/>
+              </a:ext>
+            </a:extLst>
+          </p:cNvPr>
+          <p:cNvSpPr>
+            <a:spLocks xmlns:a="http://schemas.openxmlformats.org/drawingml/2006/main" noGrp="1"/>
+          </p:cNvSpPr>
+          <p:nvPr/>
+        </p:nvSpPr>
+        <p:spPr>
+          <a:xfrm xmlns:a="http://schemas.openxmlformats.org/drawingml/2006/main">
+            <a:off x="1524000" y="4210050"/>
+            <a:ext cx="3695700" cy="361950"/>
           </a:xfrm>
           <a:prstGeom xmlns:a="http://schemas.openxmlformats.org/drawingml/2006/main" prst="rect">
             <a:avLst/>
@@ -3010,7 +3331,7 @@
           <a:lstStyle xmlns:a="http://schemas.openxmlformats.org/drawingml/2006/main"/>
           <a:p xmlns:a="http://schemas.openxmlformats.org/drawingml/2006/main">
             <a:pPr algn="l">
-              <a:defRPr sz="1350" b="0">
+              <a:defRPr sz="1275" b="0">
                 <a:solidFill>
                   <a:srgbClr val="5E6472"/>
                 </a:solidFill>
@@ -3020,7 +3341,7 @@
               </a:defRPr>
             </a:pPr>
             <a:r>
-              <a:rPr sz="1350" b="0">
+              <a:rPr sz="1275" b="0">
                 <a:solidFill>
                   <a:srgbClr val="5E6472"/>
                 </a:solidFill>
@@ -3028,89 +3349,33 @@
                 <a:ea typeface="Aptos"/>
                 <a:cs typeface="Aptos"/>
               </a:rPr>
-              <a:t>People decide what becomes official.</a:t>
+              <a:t>AI answers are grounded in the product, not generic training data.</a:t>
             </a:r>
           </a:p>
         </p:txBody>
       </p:sp>
       <p:sp>
         <p:nvSpPr>
-          <p:cNvPr id="16" name="story-arrow-2">
-            <a:extLst xmlns:a="http://schemas.openxmlformats.org/drawingml/2006/main">
-              <a:ext uri="{FF2B5EF4-FFF2-40B4-BE49-F238E27FC236}">
-                <a16:creationId xmlns:a16="http://schemas.microsoft.com/office/drawing/2014/main" id="{957A49E8-FED1-41DA-8474-83B5DA23E9E5}"/>
-              </a:ext>
-            </a:extLst>
-          </p:cNvPr>
-          <p:cNvSpPr>
-            <a:spLocks xmlns:a="http://schemas.openxmlformats.org/drawingml/2006/main" noGrp="1"/>
-          </p:cNvSpPr>
-          <p:nvPr/>
-        </p:nvSpPr>
-        <p:spPr>
-          <a:xfrm xmlns:a="http://schemas.openxmlformats.org/drawingml/2006/main">
-            <a:off x="7277100" y="3257550"/>
-            <a:ext cx="342900" cy="323850"/>
-          </a:xfrm>
-          <a:prstGeom xmlns:a="http://schemas.openxmlformats.org/drawingml/2006/main" prst="rect">
-            <a:avLst/>
-          </a:prstGeom>
-          <a:noFill xmlns:a="http://schemas.openxmlformats.org/drawingml/2006/main"/>
-          <a:ln xmlns:a="http://schemas.openxmlformats.org/drawingml/2006/main" w="0">
-            <a:noFill/>
-            <a:prstDash val="solid"/>
-          </a:ln>
-        </p:spPr>
-        <p:txBody>
-          <a:bodyPr xmlns:a="http://schemas.openxmlformats.org/drawingml/2006/main"/>
-          <a:lstStyle xmlns:a="http://schemas.openxmlformats.org/drawingml/2006/main"/>
-          <a:p xmlns:a="http://schemas.openxmlformats.org/drawingml/2006/main">
-            <a:pPr algn="ctr">
-              <a:defRPr sz="2250" b="1">
-                <a:solidFill>
-                  <a:srgbClr val="7C8CFF"/>
-                </a:solidFill>
-                <a:latin typeface="Aptos"/>
-                <a:ea typeface="Aptos"/>
-                <a:cs typeface="Aptos"/>
-              </a:defRPr>
-            </a:pPr>
-            <a:r>
-              <a:rPr sz="2250" b="1">
-                <a:solidFill>
-                  <a:srgbClr val="7C8CFF"/>
-                </a:solidFill>
-                <a:latin typeface="Aptos"/>
-                <a:ea typeface="Aptos"/>
-                <a:cs typeface="Aptos"/>
-              </a:rPr>
-              <a:t>→</a:t>
-            </a:r>
-          </a:p>
-        </p:txBody>
-      </p:sp>
-      <p:sp>
-        <p:nvSpPr>
-          <p:cNvPr id="17" name="story-step-3">
-            <a:extLst xmlns:a="http://schemas.openxmlformats.org/drawingml/2006/main">
-              <a:ext uri="{FF2B5EF4-FFF2-40B4-BE49-F238E27FC236}">
-                <a16:creationId xmlns:a16="http://schemas.microsoft.com/office/drawing/2014/main" id="{2C486E9D-7AD7-4F50-A1FC-81B6DF6740D0}"/>
-              </a:ext>
-            </a:extLst>
-          </p:cNvPr>
-          <p:cNvSpPr>
-            <a:spLocks xmlns:a="http://schemas.openxmlformats.org/drawingml/2006/main" noGrp="1"/>
-          </p:cNvSpPr>
-          <p:nvPr/>
-        </p:nvSpPr>
-        <p:spPr>
-          <a:xfrm xmlns:a="http://schemas.openxmlformats.org/drawingml/2006/main">
-            <a:off x="7791450" y="2724150"/>
-            <a:ext cx="2705100" cy="1466850"/>
+          <p:cNvPr id="20" name="prop-card-4">
+            <a:extLst xmlns:a="http://schemas.openxmlformats.org/drawingml/2006/main">
+              <a:ext uri="{FF2B5EF4-FFF2-40B4-BE49-F238E27FC236}">
+                <a16:creationId xmlns:a16="http://schemas.microsoft.com/office/drawing/2014/main" id="{325EF2B2-E200-457A-A680-AAE40B3BB91C}"/>
+              </a:ext>
+            </a:extLst>
+          </p:cNvPr>
+          <p:cNvSpPr>
+            <a:spLocks xmlns:a="http://schemas.openxmlformats.org/drawingml/2006/main" noGrp="1"/>
+          </p:cNvSpPr>
+          <p:nvPr/>
+        </p:nvSpPr>
+        <p:spPr>
+          <a:xfrm xmlns:a="http://schemas.openxmlformats.org/drawingml/2006/main">
+            <a:off x="6305550" y="3695700"/>
+            <a:ext cx="4762500" cy="1009650"/>
           </a:xfrm>
           <a:prstGeom xmlns:a="http://schemas.openxmlformats.org/drawingml/2006/main" prst="roundRect">
             <a:avLst>
-              <a:gd name="adj" fmla="val 7792"/>
+              <a:gd name="adj" fmla="val 11321"/>
             </a:avLst>
           </a:prstGeom>
           <a:solidFill xmlns:a="http://schemas.openxmlformats.org/drawingml/2006/main">
@@ -3126,22 +3391,22 @@
       </p:sp>
       <p:sp>
         <p:nvSpPr>
-          <p:cNvPr id="18" name="story-icon-3">
-            <a:extLst xmlns:a="http://schemas.openxmlformats.org/drawingml/2006/main">
-              <a:ext uri="{FF2B5EF4-FFF2-40B4-BE49-F238E27FC236}">
-                <a16:creationId xmlns:a16="http://schemas.microsoft.com/office/drawing/2014/main" id="{3F03D874-932B-4EFD-8861-181D7814A7D6}"/>
-              </a:ext>
-            </a:extLst>
-          </p:cNvPr>
-          <p:cNvSpPr>
-            <a:spLocks xmlns:a="http://schemas.openxmlformats.org/drawingml/2006/main" noGrp="1"/>
-          </p:cNvSpPr>
-          <p:nvPr/>
-        </p:nvSpPr>
-        <p:spPr>
-          <a:xfrm xmlns:a="http://schemas.openxmlformats.org/drawingml/2006/main">
-            <a:off x="8058150" y="2990850"/>
-            <a:ext cx="419100" cy="419100"/>
+          <p:cNvPr id="21" name="prop-icon-4">
+            <a:extLst xmlns:a="http://schemas.openxmlformats.org/drawingml/2006/main">
+              <a:ext uri="{FF2B5EF4-FFF2-40B4-BE49-F238E27FC236}">
+                <a16:creationId xmlns:a16="http://schemas.microsoft.com/office/drawing/2014/main" id="{4E8D89ED-6332-42AC-862D-3A9C14219D0D}"/>
+              </a:ext>
+            </a:extLst>
+          </p:cNvPr>
+          <p:cNvSpPr>
+            <a:spLocks xmlns:a="http://schemas.openxmlformats.org/drawingml/2006/main" noGrp="1"/>
+          </p:cNvSpPr>
+          <p:nvPr/>
+        </p:nvSpPr>
+        <p:spPr>
+          <a:xfrm xmlns:a="http://schemas.openxmlformats.org/drawingml/2006/main">
+            <a:off x="6553200" y="3924300"/>
+            <a:ext cx="342900" cy="342900"/>
           </a:xfrm>
           <a:prstGeom xmlns:a="http://schemas.openxmlformats.org/drawingml/2006/main" prst="ellipse">
             <a:avLst/>
@@ -3157,22 +3422,22 @@
       </p:sp>
       <p:sp>
         <p:nvSpPr>
-          <p:cNvPr id="19" name="story-num-3">
-            <a:extLst xmlns:a="http://schemas.openxmlformats.org/drawingml/2006/main">
-              <a:ext uri="{FF2B5EF4-FFF2-40B4-BE49-F238E27FC236}">
-                <a16:creationId xmlns:a16="http://schemas.microsoft.com/office/drawing/2014/main" id="{2D3EF215-C7D2-478E-978F-18D89B619D13}"/>
-              </a:ext>
-            </a:extLst>
-          </p:cNvPr>
-          <p:cNvSpPr>
-            <a:spLocks xmlns:a="http://schemas.openxmlformats.org/drawingml/2006/main" noGrp="1"/>
-          </p:cNvSpPr>
-          <p:nvPr/>
-        </p:nvSpPr>
-        <p:spPr>
-          <a:xfrm xmlns:a="http://schemas.openxmlformats.org/drawingml/2006/main">
-            <a:off x="8191500" y="3086100"/>
-            <a:ext cx="152400" cy="190500"/>
+          <p:cNvPr id="22" name="prop-num-4">
+            <a:extLst xmlns:a="http://schemas.openxmlformats.org/drawingml/2006/main">
+              <a:ext uri="{FF2B5EF4-FFF2-40B4-BE49-F238E27FC236}">
+                <a16:creationId xmlns:a16="http://schemas.microsoft.com/office/drawing/2014/main" id="{E80C86D5-0CA2-4CA9-9BB7-72C3364FDA36}"/>
+              </a:ext>
+            </a:extLst>
+          </p:cNvPr>
+          <p:cNvSpPr>
+            <a:spLocks xmlns:a="http://schemas.openxmlformats.org/drawingml/2006/main" noGrp="1"/>
+          </p:cNvSpPr>
+          <p:nvPr/>
+        </p:nvSpPr>
+        <p:spPr>
+          <a:xfrm xmlns:a="http://schemas.openxmlformats.org/drawingml/2006/main">
+            <a:off x="6667500" y="4000500"/>
+            <a:ext cx="114300" cy="152400"/>
           </a:xfrm>
           <a:prstGeom xmlns:a="http://schemas.openxmlformats.org/drawingml/2006/main" prst="rect">
             <a:avLst/>
@@ -3188,7 +3453,7 @@
           <a:lstStyle xmlns:a="http://schemas.openxmlformats.org/drawingml/2006/main"/>
           <a:p xmlns:a="http://schemas.openxmlformats.org/drawingml/2006/main">
             <a:pPr algn="ctr">
-              <a:defRPr sz="1200" b="1">
+              <a:defRPr sz="975" b="1">
                 <a:solidFill>
                   <a:srgbClr val="FFFFFF"/>
                 </a:solidFill>
@@ -3198,7 +3463,7 @@
               </a:defRPr>
             </a:pPr>
             <a:r>
-              <a:rPr sz="1200" b="1">
+              <a:rPr sz="975" b="1">
                 <a:solidFill>
                   <a:srgbClr val="FFFFFF"/>
                 </a:solidFill>
@@ -3206,29 +3471,29 @@
                 <a:ea typeface="Aptos"/>
                 <a:cs typeface="Aptos"/>
               </a:rPr>
-              <a:t>3</a:t>
+              <a:t>4</a:t>
             </a:r>
           </a:p>
         </p:txBody>
       </p:sp>
       <p:sp>
         <p:nvSpPr>
-          <p:cNvPr id="20" name="story-heading-3">
-            <a:extLst xmlns:a="http://schemas.openxmlformats.org/drawingml/2006/main">
-              <a:ext uri="{FF2B5EF4-FFF2-40B4-BE49-F238E27FC236}">
-                <a16:creationId xmlns:a16="http://schemas.microsoft.com/office/drawing/2014/main" id="{2773B6FD-EA52-49E9-9D26-DEC014D8113C}"/>
-              </a:ext>
-            </a:extLst>
-          </p:cNvPr>
-          <p:cNvSpPr>
-            <a:spLocks xmlns:a="http://schemas.openxmlformats.org/drawingml/2006/main" noGrp="1"/>
-          </p:cNvSpPr>
-          <p:nvPr/>
-        </p:nvSpPr>
-        <p:spPr>
-          <a:xfrm xmlns:a="http://schemas.openxmlformats.org/drawingml/2006/main">
-            <a:off x="8667750" y="3028950"/>
-            <a:ext cx="1428750" cy="266700"/>
+          <p:cNvPr id="23" name="prop-heading-4">
+            <a:extLst xmlns:a="http://schemas.openxmlformats.org/drawingml/2006/main">
+              <a:ext uri="{FF2B5EF4-FFF2-40B4-BE49-F238E27FC236}">
+                <a16:creationId xmlns:a16="http://schemas.microsoft.com/office/drawing/2014/main" id="{7C333B88-0465-44DA-BC03-A53CE57CE51F}"/>
+              </a:ext>
+            </a:extLst>
+          </p:cNvPr>
+          <p:cNvSpPr>
+            <a:spLocks xmlns:a="http://schemas.openxmlformats.org/drawingml/2006/main" noGrp="1"/>
+          </p:cNvSpPr>
+          <p:nvPr/>
+        </p:nvSpPr>
+        <p:spPr>
+          <a:xfrm xmlns:a="http://schemas.openxmlformats.org/drawingml/2006/main">
+            <a:off x="7048500" y="3886200"/>
+            <a:ext cx="3714750" cy="247650"/>
           </a:xfrm>
           <a:prstGeom xmlns:a="http://schemas.openxmlformats.org/drawingml/2006/main" prst="rect">
             <a:avLst/>
@@ -3244,7 +3509,7 @@
           <a:lstStyle xmlns:a="http://schemas.openxmlformats.org/drawingml/2006/main"/>
           <a:p xmlns:a="http://schemas.openxmlformats.org/drawingml/2006/main">
             <a:pPr algn="l">
-              <a:defRPr sz="1875" b="1">
+              <a:defRPr sz="1725" b="1">
                 <a:solidFill>
                   <a:srgbClr val="12121A"/>
                 </a:solidFill>
@@ -3254,7 +3519,7 @@
               </a:defRPr>
             </a:pPr>
             <a:r>
-              <a:rPr sz="1875" b="1">
+              <a:rPr sz="1725" b="1">
                 <a:solidFill>
                   <a:srgbClr val="12121A"/>
                 </a:solidFill>
@@ -3262,29 +3527,29 @@
                 <a:ea typeface="Aptos"/>
                 <a:cs typeface="Aptos"/>
               </a:rPr>
-              <a:t>Reuse</a:t>
+              <a:t>Save tokens and time</a:t>
             </a:r>
           </a:p>
         </p:txBody>
       </p:sp>
       <p:sp>
         <p:nvSpPr>
-          <p:cNvPr id="21" name="story-body-3">
-            <a:extLst xmlns:a="http://schemas.openxmlformats.org/drawingml/2006/main">
-              <a:ext uri="{FF2B5EF4-FFF2-40B4-BE49-F238E27FC236}">
-                <a16:creationId xmlns:a16="http://schemas.microsoft.com/office/drawing/2014/main" id="{67DFEB30-62F1-42F5-83BC-CB5A0910DE28}"/>
-              </a:ext>
-            </a:extLst>
-          </p:cNvPr>
-          <p:cNvSpPr>
-            <a:spLocks xmlns:a="http://schemas.openxmlformats.org/drawingml/2006/main" noGrp="1"/>
-          </p:cNvSpPr>
-          <p:nvPr/>
-        </p:nvSpPr>
-        <p:spPr>
-          <a:xfrm xmlns:a="http://schemas.openxmlformats.org/drawingml/2006/main">
-            <a:off x="8077200" y="3562350"/>
-            <a:ext cx="2095500" cy="400050"/>
+          <p:cNvPr id="24" name="prop-body-4">
+            <a:extLst xmlns:a="http://schemas.openxmlformats.org/drawingml/2006/main">
+              <a:ext uri="{FF2B5EF4-FFF2-40B4-BE49-F238E27FC236}">
+                <a16:creationId xmlns:a16="http://schemas.microsoft.com/office/drawing/2014/main" id="{5958FC22-A24D-4038-81E2-8C88A93A1C7B}"/>
+              </a:ext>
+            </a:extLst>
+          </p:cNvPr>
+          <p:cNvSpPr>
+            <a:spLocks xmlns:a="http://schemas.openxmlformats.org/drawingml/2006/main" noGrp="1"/>
+          </p:cNvSpPr>
+          <p:nvPr/>
+        </p:nvSpPr>
+        <p:spPr>
+          <a:xfrm xmlns:a="http://schemas.openxmlformats.org/drawingml/2006/main">
+            <a:off x="7048500" y="4210050"/>
+            <a:ext cx="3695700" cy="361950"/>
           </a:xfrm>
           <a:prstGeom xmlns:a="http://schemas.openxmlformats.org/drawingml/2006/main" prst="rect">
             <a:avLst/>
@@ -3300,7 +3565,7 @@
           <a:lstStyle xmlns:a="http://schemas.openxmlformats.org/drawingml/2006/main"/>
           <a:p xmlns:a="http://schemas.openxmlformats.org/drawingml/2006/main">
             <a:pPr algn="l">
-              <a:defRPr sz="1350" b="0">
+              <a:defRPr sz="1275" b="0">
                 <a:solidFill>
                   <a:srgbClr val="5E6472"/>
                 </a:solidFill>
@@ -3310,7 +3575,7 @@
               </a:defRPr>
             </a:pPr>
             <a:r>
-              <a:rPr sz="1350" b="0">
+              <a:rPr sz="1275" b="0">
                 <a:solidFill>
                   <a:srgbClr val="5E6472"/>
                 </a:solidFill>
@@ -3318,29 +3583,263 @@
                 <a:ea typeface="Aptos"/>
                 <a:cs typeface="Aptos"/>
               </a:rPr>
-              <a:t>The same guidance follows teams into AI tools.</a:t>
+              <a:t>Teams stop re-explaining the same context in every prompt and review cycle.</a:t>
             </a:r>
           </a:p>
         </p:txBody>
       </p:sp>
       <p:sp>
         <p:nvSpPr>
-          <p:cNvPr id="22" name="outcome-band">
-            <a:extLst xmlns:a="http://schemas.openxmlformats.org/drawingml/2006/main">
-              <a:ext uri="{FF2B5EF4-FFF2-40B4-BE49-F238E27FC236}">
-                <a16:creationId xmlns:a16="http://schemas.microsoft.com/office/drawing/2014/main" id="{BB46B144-AC85-407C-A6E5-8616BAE8A866}"/>
-              </a:ext>
-            </a:extLst>
-          </p:cNvPr>
-          <p:cNvSpPr>
-            <a:spLocks xmlns:a="http://schemas.openxmlformats.org/drawingml/2006/main" noGrp="1"/>
-          </p:cNvSpPr>
-          <p:nvPr/>
-        </p:nvSpPr>
-        <p:spPr>
-          <a:xfrm xmlns:a="http://schemas.openxmlformats.org/drawingml/2006/main">
-            <a:off x="1695450" y="4857750"/>
-            <a:ext cx="8801100" cy="723900"/>
+          <p:cNvPr id="25" name="prop-card-5">
+            <a:extLst xmlns:a="http://schemas.openxmlformats.org/drawingml/2006/main">
+              <a:ext uri="{FF2B5EF4-FFF2-40B4-BE49-F238E27FC236}">
+                <a16:creationId xmlns:a16="http://schemas.microsoft.com/office/drawing/2014/main" id="{3DDE24BC-F960-4A20-8D19-04C35E219FCD}"/>
+              </a:ext>
+            </a:extLst>
+          </p:cNvPr>
+          <p:cNvSpPr>
+            <a:spLocks xmlns:a="http://schemas.openxmlformats.org/drawingml/2006/main" noGrp="1"/>
+          </p:cNvSpPr>
+          <p:nvPr/>
+        </p:nvSpPr>
+        <p:spPr>
+          <a:xfrm xmlns:a="http://schemas.openxmlformats.org/drawingml/2006/main">
+            <a:off x="2667000" y="5010150"/>
+            <a:ext cx="6858000" cy="1009650"/>
+          </a:xfrm>
+          <a:prstGeom xmlns:a="http://schemas.openxmlformats.org/drawingml/2006/main" prst="roundRect">
+            <a:avLst>
+              <a:gd name="adj" fmla="val 11321"/>
+            </a:avLst>
+          </a:prstGeom>
+          <a:solidFill xmlns:a="http://schemas.openxmlformats.org/drawingml/2006/main">
+            <a:srgbClr val="FFFFFF"/>
+          </a:solidFill>
+          <a:ln xmlns:a="http://schemas.openxmlformats.org/drawingml/2006/main" w="9525">
+            <a:solidFill>
+              <a:srgbClr val="D8DDF2"/>
+            </a:solidFill>
+            <a:prstDash val="solid"/>
+          </a:ln>
+        </p:spPr>
+      </p:sp>
+      <p:sp>
+        <p:nvSpPr>
+          <p:cNvPr id="26" name="prop-icon-5">
+            <a:extLst xmlns:a="http://schemas.openxmlformats.org/drawingml/2006/main">
+              <a:ext uri="{FF2B5EF4-FFF2-40B4-BE49-F238E27FC236}">
+                <a16:creationId xmlns:a16="http://schemas.microsoft.com/office/drawing/2014/main" id="{09D50F60-721D-4531-92D1-A818FEDD716B}"/>
+              </a:ext>
+            </a:extLst>
+          </p:cNvPr>
+          <p:cNvSpPr>
+            <a:spLocks xmlns:a="http://schemas.openxmlformats.org/drawingml/2006/main" noGrp="1"/>
+          </p:cNvSpPr>
+          <p:nvPr/>
+        </p:nvSpPr>
+        <p:spPr>
+          <a:xfrm xmlns:a="http://schemas.openxmlformats.org/drawingml/2006/main">
+            <a:off x="2914650" y="5238750"/>
+            <a:ext cx="342900" cy="342900"/>
+          </a:xfrm>
+          <a:prstGeom xmlns:a="http://schemas.openxmlformats.org/drawingml/2006/main" prst="ellipse">
+            <a:avLst/>
+          </a:prstGeom>
+          <a:solidFill xmlns:a="http://schemas.openxmlformats.org/drawingml/2006/main">
+            <a:srgbClr val="7C8CFF"/>
+          </a:solidFill>
+          <a:ln xmlns:a="http://schemas.openxmlformats.org/drawingml/2006/main" w="0">
+            <a:noFill/>
+            <a:prstDash val="solid"/>
+          </a:ln>
+        </p:spPr>
+      </p:sp>
+      <p:sp>
+        <p:nvSpPr>
+          <p:cNvPr id="27" name="prop-num-5">
+            <a:extLst xmlns:a="http://schemas.openxmlformats.org/drawingml/2006/main">
+              <a:ext uri="{FF2B5EF4-FFF2-40B4-BE49-F238E27FC236}">
+                <a16:creationId xmlns:a16="http://schemas.microsoft.com/office/drawing/2014/main" id="{2C276E0F-1D13-40D5-9F39-4963830CAA69}"/>
+              </a:ext>
+            </a:extLst>
+          </p:cNvPr>
+          <p:cNvSpPr>
+            <a:spLocks xmlns:a="http://schemas.openxmlformats.org/drawingml/2006/main" noGrp="1"/>
+          </p:cNvSpPr>
+          <p:nvPr/>
+        </p:nvSpPr>
+        <p:spPr>
+          <a:xfrm xmlns:a="http://schemas.openxmlformats.org/drawingml/2006/main">
+            <a:off x="3028950" y="5314950"/>
+            <a:ext cx="114300" cy="152400"/>
+          </a:xfrm>
+          <a:prstGeom xmlns:a="http://schemas.openxmlformats.org/drawingml/2006/main" prst="rect">
+            <a:avLst/>
+          </a:prstGeom>
+          <a:noFill xmlns:a="http://schemas.openxmlformats.org/drawingml/2006/main"/>
+          <a:ln xmlns:a="http://schemas.openxmlformats.org/drawingml/2006/main" w="0">
+            <a:noFill/>
+            <a:prstDash val="solid"/>
+          </a:ln>
+        </p:spPr>
+        <p:txBody>
+          <a:bodyPr xmlns:a="http://schemas.openxmlformats.org/drawingml/2006/main"/>
+          <a:lstStyle xmlns:a="http://schemas.openxmlformats.org/drawingml/2006/main"/>
+          <a:p xmlns:a="http://schemas.openxmlformats.org/drawingml/2006/main">
+            <a:pPr algn="ctr">
+              <a:defRPr sz="975" b="1">
+                <a:solidFill>
+                  <a:srgbClr val="FFFFFF"/>
+                </a:solidFill>
+                <a:latin typeface="Aptos"/>
+                <a:ea typeface="Aptos"/>
+                <a:cs typeface="Aptos"/>
+              </a:defRPr>
+            </a:pPr>
+            <a:r>
+              <a:rPr sz="975" b="1">
+                <a:solidFill>
+                  <a:srgbClr val="FFFFFF"/>
+                </a:solidFill>
+                <a:latin typeface="Aptos"/>
+                <a:ea typeface="Aptos"/>
+                <a:cs typeface="Aptos"/>
+              </a:rPr>
+              <a:t>5</a:t>
+            </a:r>
+          </a:p>
+        </p:txBody>
+      </p:sp>
+      <p:sp>
+        <p:nvSpPr>
+          <p:cNvPr id="28" name="prop-heading-5">
+            <a:extLst xmlns:a="http://schemas.openxmlformats.org/drawingml/2006/main">
+              <a:ext uri="{FF2B5EF4-FFF2-40B4-BE49-F238E27FC236}">
+                <a16:creationId xmlns:a16="http://schemas.microsoft.com/office/drawing/2014/main" id="{234D4DF7-95F5-4AC2-A22F-B2F6CF59D703}"/>
+              </a:ext>
+            </a:extLst>
+          </p:cNvPr>
+          <p:cNvSpPr>
+            <a:spLocks xmlns:a="http://schemas.openxmlformats.org/drawingml/2006/main" noGrp="1"/>
+          </p:cNvSpPr>
+          <p:nvPr/>
+        </p:nvSpPr>
+        <p:spPr>
+          <a:xfrm xmlns:a="http://schemas.openxmlformats.org/drawingml/2006/main">
+            <a:off x="3409950" y="5200650"/>
+            <a:ext cx="5810250" cy="247650"/>
+          </a:xfrm>
+          <a:prstGeom xmlns:a="http://schemas.openxmlformats.org/drawingml/2006/main" prst="rect">
+            <a:avLst/>
+          </a:prstGeom>
+          <a:noFill xmlns:a="http://schemas.openxmlformats.org/drawingml/2006/main"/>
+          <a:ln xmlns:a="http://schemas.openxmlformats.org/drawingml/2006/main" w="0">
+            <a:noFill/>
+            <a:prstDash val="solid"/>
+          </a:ln>
+        </p:spPr>
+        <p:txBody>
+          <a:bodyPr xmlns:a="http://schemas.openxmlformats.org/drawingml/2006/main"/>
+          <a:lstStyle xmlns:a="http://schemas.openxmlformats.org/drawingml/2006/main"/>
+          <a:p xmlns:a="http://schemas.openxmlformats.org/drawingml/2006/main">
+            <a:pPr algn="l">
+              <a:defRPr sz="1725" b="1">
+                <a:solidFill>
+                  <a:srgbClr val="12121A"/>
+                </a:solidFill>
+                <a:latin typeface="Aptos"/>
+                <a:ea typeface="Aptos"/>
+                <a:cs typeface="Aptos"/>
+              </a:defRPr>
+            </a:pPr>
+            <a:r>
+              <a:rPr sz="1725" b="1">
+                <a:solidFill>
+                  <a:srgbClr val="12121A"/>
+                </a:solidFill>
+                <a:latin typeface="Aptos"/>
+                <a:ea typeface="Aptos"/>
+                <a:cs typeface="Aptos"/>
+              </a:rPr>
+              <a:t>Consistent code</a:t>
+            </a:r>
+          </a:p>
+        </p:txBody>
+      </p:sp>
+      <p:sp>
+        <p:nvSpPr>
+          <p:cNvPr id="29" name="prop-body-5">
+            <a:extLst xmlns:a="http://schemas.openxmlformats.org/drawingml/2006/main">
+              <a:ext uri="{FF2B5EF4-FFF2-40B4-BE49-F238E27FC236}">
+                <a16:creationId xmlns:a16="http://schemas.microsoft.com/office/drawing/2014/main" id="{EF4CDCCE-1287-4A01-A305-634FA0F8F30D}"/>
+              </a:ext>
+            </a:extLst>
+          </p:cNvPr>
+          <p:cNvSpPr>
+            <a:spLocks xmlns:a="http://schemas.openxmlformats.org/drawingml/2006/main" noGrp="1"/>
+          </p:cNvSpPr>
+          <p:nvPr/>
+        </p:nvSpPr>
+        <p:spPr>
+          <a:xfrm xmlns:a="http://schemas.openxmlformats.org/drawingml/2006/main">
+            <a:off x="3409950" y="5524500"/>
+            <a:ext cx="5791200" cy="361950"/>
+          </a:xfrm>
+          <a:prstGeom xmlns:a="http://schemas.openxmlformats.org/drawingml/2006/main" prst="rect">
+            <a:avLst/>
+          </a:prstGeom>
+          <a:noFill xmlns:a="http://schemas.openxmlformats.org/drawingml/2006/main"/>
+          <a:ln xmlns:a="http://schemas.openxmlformats.org/drawingml/2006/main" w="0">
+            <a:noFill/>
+            <a:prstDash val="solid"/>
+          </a:ln>
+        </p:spPr>
+        <p:txBody>
+          <a:bodyPr xmlns:a="http://schemas.openxmlformats.org/drawingml/2006/main"/>
+          <a:lstStyle xmlns:a="http://schemas.openxmlformats.org/drawingml/2006/main"/>
+          <a:p xmlns:a="http://schemas.openxmlformats.org/drawingml/2006/main">
+            <a:pPr algn="l">
+              <a:defRPr sz="1275" b="0">
+                <a:solidFill>
+                  <a:srgbClr val="5E6472"/>
+                </a:solidFill>
+                <a:latin typeface="Aptos"/>
+                <a:ea typeface="Aptos"/>
+                <a:cs typeface="Aptos"/>
+              </a:defRPr>
+            </a:pPr>
+            <a:r>
+              <a:rPr sz="1275" b="0">
+                <a:solidFill>
+                  <a:srgbClr val="5E6472"/>
+                </a:solidFill>
+                <a:latin typeface="Aptos"/>
+                <a:ea typeface="Aptos"/>
+                <a:cs typeface="Aptos"/>
+              </a:rPr>
+              <a:t>AI suggestions follow the product’s actual patterns, boundaries, and standards.</a:t>
+            </a:r>
+          </a:p>
+        </p:txBody>
+      </p:sp>
+      <p:sp>
+        <p:nvSpPr>
+          <p:cNvPr id="30" name="prop-band">
+            <a:extLst xmlns:a="http://schemas.openxmlformats.org/drawingml/2006/main">
+              <a:ext uri="{FF2B5EF4-FFF2-40B4-BE49-F238E27FC236}">
+                <a16:creationId xmlns:a16="http://schemas.microsoft.com/office/drawing/2014/main" id="{02C7B1AC-FFE0-42A5-A887-FC4890368212}"/>
+              </a:ext>
+            </a:extLst>
+          </p:cNvPr>
+          <p:cNvSpPr>
+            <a:spLocks xmlns:a="http://schemas.openxmlformats.org/drawingml/2006/main" noGrp="1"/>
+          </p:cNvSpPr>
+          <p:nvPr/>
+        </p:nvSpPr>
+        <p:spPr>
+          <a:xfrm xmlns:a="http://schemas.openxmlformats.org/drawingml/2006/main">
+            <a:off x="2476500" y="6210300"/>
+            <a:ext cx="7239000" cy="400050"/>
           </a:xfrm>
           <a:prstGeom xmlns:a="http://schemas.openxmlformats.org/drawingml/2006/main" prst="roundRect">
             <a:avLst>
@@ -3358,22 +3857,22 @@
       </p:sp>
       <p:sp>
         <p:nvSpPr>
-          <p:cNvPr id="23" name="outcome-band-text">
-            <a:extLst xmlns:a="http://schemas.openxmlformats.org/drawingml/2006/main">
-              <a:ext uri="{FF2B5EF4-FFF2-40B4-BE49-F238E27FC236}">
-                <a16:creationId xmlns:a16="http://schemas.microsoft.com/office/drawing/2014/main" id="{65030EAB-7749-4924-95CA-E3A7F5D39B77}"/>
-              </a:ext>
-            </a:extLst>
-          </p:cNvPr>
-          <p:cNvSpPr>
-            <a:spLocks xmlns:a="http://schemas.openxmlformats.org/drawingml/2006/main" noGrp="1"/>
-          </p:cNvSpPr>
-          <p:nvPr/>
-        </p:nvSpPr>
-        <p:spPr>
-          <a:xfrm xmlns:a="http://schemas.openxmlformats.org/drawingml/2006/main">
-            <a:off x="2228850" y="5067300"/>
-            <a:ext cx="7734300" cy="266700"/>
+          <p:cNvPr id="31" name="prop-band-text">
+            <a:extLst xmlns:a="http://schemas.openxmlformats.org/drawingml/2006/main">
+              <a:ext uri="{FF2B5EF4-FFF2-40B4-BE49-F238E27FC236}">
+                <a16:creationId xmlns:a16="http://schemas.microsoft.com/office/drawing/2014/main" id="{77DB906E-57F5-4E2D-BECF-42F1815BBAF3}"/>
+              </a:ext>
+            </a:extLst>
+          </p:cNvPr>
+          <p:cNvSpPr>
+            <a:spLocks xmlns:a="http://schemas.openxmlformats.org/drawingml/2006/main" noGrp="1"/>
+          </p:cNvSpPr>
+          <p:nvPr/>
+        </p:nvSpPr>
+        <p:spPr>
+          <a:xfrm xmlns:a="http://schemas.openxmlformats.org/drawingml/2006/main">
+            <a:off x="2990850" y="6315075"/>
+            <a:ext cx="6191250" cy="171450"/>
           </a:xfrm>
           <a:prstGeom xmlns:a="http://schemas.openxmlformats.org/drawingml/2006/main" prst="rect">
             <a:avLst/>
@@ -3389,7 +3888,7 @@
           <a:lstStyle xmlns:a="http://schemas.openxmlformats.org/drawingml/2006/main"/>
           <a:p xmlns:a="http://schemas.openxmlformats.org/drawingml/2006/main">
             <a:pPr algn="ctr">
-              <a:defRPr sz="1575" b="1">
+              <a:defRPr sz="1275" b="1">
                 <a:solidFill>
                   <a:srgbClr val="FFFFFF"/>
                 </a:solidFill>
@@ -3399,7 +3898,7 @@
               </a:defRPr>
             </a:pPr>
             <a:r>
-              <a:rPr sz="1575" b="1">
+              <a:rPr sz="1275" b="1">
                 <a:solidFill>
                   <a:srgbClr val="FFFFFF"/>
                 </a:solidFill>
@@ -3407,17 +3906,17 @@
                 <a:ea typeface="Aptos"/>
                 <a:cs typeface="Aptos"/>
               </a:rPr>
-              <a:t>What business people should see: faster onboarding, more consistent AI, and clearer accountability.</a:t>
+              <a:t>Bottom line: faster delivery with less AI guesswork.</a:t>
             </a:r>
           </a:p>
         </p:txBody>
       </p:sp>
       <p:sp>
         <p:nvSpPr>
-          <p:cNvPr id="24" name="footer-2">
-            <a:extLst xmlns:a="http://schemas.openxmlformats.org/drawingml/2006/main">
-              <a:ext uri="{FF2B5EF4-FFF2-40B4-BE49-F238E27FC236}">
-                <a16:creationId xmlns:a16="http://schemas.microsoft.com/office/drawing/2014/main" id="{6FDB6207-A9CD-4646-94CC-F2BE133AD0EF}"/>
+          <p:cNvPr id="32" name="footer-2">
+            <a:extLst xmlns:a="http://schemas.openxmlformats.org/drawingml/2006/main">
+              <a:ext uri="{FF2B5EF4-FFF2-40B4-BE49-F238E27FC236}">
+                <a16:creationId xmlns:a16="http://schemas.microsoft.com/office/drawing/2014/main" id="{607BCA76-2A6E-4BB4-99E9-D963E0C79086}"/>
               </a:ext>
             </a:extLst>
           </p:cNvPr>
@@ -3471,7 +3970,7 @@
     </p:spTree>
     <p:extLst>
       <p:ext uri="{BB962C8B-B14F-4D97-AF65-F5344CB8AC3E}">
-        <p14:creationId xmlns:p14="http://schemas.microsoft.com/office/powerpoint/2010/main" val="358570631"/>
+        <p14:creationId xmlns:p14="http://schemas.microsoft.com/office/powerpoint/2010/main" val="951213962"/>
       </p:ext>
     </p:extLst>
   </p:cSld>

</xml_diff>